<commit_message>
Adapt workshop delivery for a large room with individual checkpoints
</commit_message>
<xml_diff>
--- a/slides/Agentic AI in Practice.pptx
+++ b/slides/Agentic AI in Practice.pptx
@@ -2,43 +2,43 @@
 <file path=ppt/presentation.xml><?xml version="1.0" encoding="utf-8"?>
 <p:presentation xmlns:p="http://schemas.openxmlformats.org/presentationml/2006/main">
   <p:sldMasterIdLst>
-    <p:sldMasterId xmlns:r="http://schemas.openxmlformats.org/officeDocument/2006/relationships" id="2147483648" r:id="R4b2730e3f3314f06"/>
+    <p:sldMasterId xmlns:r="http://schemas.openxmlformats.org/officeDocument/2006/relationships" id="2147483648" r:id="R2832cd56a7ff4629"/>
   </p:sldMasterIdLst>
   <p:notesMasterIdLst>
-    <p:notesMasterId xmlns:r="http://schemas.openxmlformats.org/officeDocument/2006/relationships" r:id="R44263459020a421e"/>
+    <p:notesMasterId xmlns:r="http://schemas.openxmlformats.org/officeDocument/2006/relationships" r:id="Rfafb3a7061644244"/>
   </p:notesMasterIdLst>
   <p:sldIdLst>
-    <p:sldId xmlns:r="http://schemas.openxmlformats.org/officeDocument/2006/relationships" id="256" r:id="R6f70438c3e744e4d"/>
-    <p:sldId xmlns:r="http://schemas.openxmlformats.org/officeDocument/2006/relationships" id="257" r:id="Ra3a03257ca6d4d06"/>
-    <p:sldId xmlns:r="http://schemas.openxmlformats.org/officeDocument/2006/relationships" id="258" r:id="R8f5830012ac74b4e"/>
-    <p:sldId xmlns:r="http://schemas.openxmlformats.org/officeDocument/2006/relationships" id="259" r:id="Ref351d55184b4216"/>
-    <p:sldId xmlns:r="http://schemas.openxmlformats.org/officeDocument/2006/relationships" id="260" r:id="Rdf02b9c88bda43bf"/>
-    <p:sldId xmlns:r="http://schemas.openxmlformats.org/officeDocument/2006/relationships" id="261" r:id="R366ffab00c25440f"/>
-    <p:sldId xmlns:r="http://schemas.openxmlformats.org/officeDocument/2006/relationships" id="262" r:id="R21a7c541947c4d12"/>
-    <p:sldId xmlns:r="http://schemas.openxmlformats.org/officeDocument/2006/relationships" id="263" r:id="Rfc2d96b872c14fae"/>
-    <p:sldId xmlns:r="http://schemas.openxmlformats.org/officeDocument/2006/relationships" id="264" r:id="R8b5beaff61644b1e"/>
-    <p:sldId xmlns:r="http://schemas.openxmlformats.org/officeDocument/2006/relationships" id="265" r:id="R824c5d93469544e4"/>
-    <p:sldId xmlns:r="http://schemas.openxmlformats.org/officeDocument/2006/relationships" id="266" r:id="R4ac68097491f4c07"/>
-    <p:sldId xmlns:r="http://schemas.openxmlformats.org/officeDocument/2006/relationships" id="267" r:id="R88b09a4ef53b4b5c"/>
-    <p:sldId xmlns:r="http://schemas.openxmlformats.org/officeDocument/2006/relationships" id="268" r:id="Rb653ae9fb345454f"/>
-    <p:sldId xmlns:r="http://schemas.openxmlformats.org/officeDocument/2006/relationships" id="269" r:id="Re6e87bd5e2414462"/>
-    <p:sldId xmlns:r="http://schemas.openxmlformats.org/officeDocument/2006/relationships" id="270" r:id="Rb1861cce880b491f"/>
-    <p:sldId xmlns:r="http://schemas.openxmlformats.org/officeDocument/2006/relationships" id="271" r:id="R21556c6599fe46dc"/>
-    <p:sldId xmlns:r="http://schemas.openxmlformats.org/officeDocument/2006/relationships" id="272" r:id="Rc441409589ae4d2f"/>
-    <p:sldId xmlns:r="http://schemas.openxmlformats.org/officeDocument/2006/relationships" id="273" r:id="R0434f47beea14625"/>
-    <p:sldId xmlns:r="http://schemas.openxmlformats.org/officeDocument/2006/relationships" id="274" r:id="R6f762a1b0e8744ba"/>
-    <p:sldId xmlns:r="http://schemas.openxmlformats.org/officeDocument/2006/relationships" id="275" r:id="Re4a1e5e0ed094e2f"/>
-    <p:sldId xmlns:r="http://schemas.openxmlformats.org/officeDocument/2006/relationships" id="276" r:id="R47c3248e755f44c4"/>
-    <p:sldId xmlns:r="http://schemas.openxmlformats.org/officeDocument/2006/relationships" id="277" r:id="Rd3577689476e4352"/>
-    <p:sldId xmlns:r="http://schemas.openxmlformats.org/officeDocument/2006/relationships" id="278" r:id="R582e1646156341e9"/>
-    <p:sldId xmlns:r="http://schemas.openxmlformats.org/officeDocument/2006/relationships" id="279" r:id="Rde73a1f7ae6242f9"/>
-    <p:sldId xmlns:r="http://schemas.openxmlformats.org/officeDocument/2006/relationships" id="280" r:id="R8d50e18f62574172"/>
-    <p:sldId xmlns:r="http://schemas.openxmlformats.org/officeDocument/2006/relationships" id="281" r:id="Rcd5beae671394828"/>
-    <p:sldId xmlns:r="http://schemas.openxmlformats.org/officeDocument/2006/relationships" id="282" r:id="R6bda415aed09495f"/>
-    <p:sldId xmlns:r="http://schemas.openxmlformats.org/officeDocument/2006/relationships" id="283" r:id="R3326c75acd3542c7"/>
-    <p:sldId xmlns:r="http://schemas.openxmlformats.org/officeDocument/2006/relationships" id="284" r:id="R230e1a51673c4d6c"/>
-    <p:sldId xmlns:r="http://schemas.openxmlformats.org/officeDocument/2006/relationships" id="285" r:id="Ra6375863381f499d"/>
-    <p:sldId xmlns:r="http://schemas.openxmlformats.org/officeDocument/2006/relationships" id="286" r:id="R6bfeeceda1c3409b"/>
+    <p:sldId xmlns:r="http://schemas.openxmlformats.org/officeDocument/2006/relationships" id="256" r:id="R3df5c00c0d124790"/>
+    <p:sldId xmlns:r="http://schemas.openxmlformats.org/officeDocument/2006/relationships" id="257" r:id="Rdd9ec91f29e84492"/>
+    <p:sldId xmlns:r="http://schemas.openxmlformats.org/officeDocument/2006/relationships" id="258" r:id="R0841f3c06e8c4be4"/>
+    <p:sldId xmlns:r="http://schemas.openxmlformats.org/officeDocument/2006/relationships" id="259" r:id="Reb6741a8331f4653"/>
+    <p:sldId xmlns:r="http://schemas.openxmlformats.org/officeDocument/2006/relationships" id="260" r:id="R4dd71c531b1f45a2"/>
+    <p:sldId xmlns:r="http://schemas.openxmlformats.org/officeDocument/2006/relationships" id="261" r:id="Rc7c6923045ba47bf"/>
+    <p:sldId xmlns:r="http://schemas.openxmlformats.org/officeDocument/2006/relationships" id="262" r:id="Rf1df96d4433c49d0"/>
+    <p:sldId xmlns:r="http://schemas.openxmlformats.org/officeDocument/2006/relationships" id="263" r:id="R77fefdb8ea1e4a66"/>
+    <p:sldId xmlns:r="http://schemas.openxmlformats.org/officeDocument/2006/relationships" id="264" r:id="Rb34b6077b6674e0a"/>
+    <p:sldId xmlns:r="http://schemas.openxmlformats.org/officeDocument/2006/relationships" id="265" r:id="Re1a85c6e8edb4698"/>
+    <p:sldId xmlns:r="http://schemas.openxmlformats.org/officeDocument/2006/relationships" id="266" r:id="R4603b8843fd24c9a"/>
+    <p:sldId xmlns:r="http://schemas.openxmlformats.org/officeDocument/2006/relationships" id="267" r:id="R13cb094d952b4a0e"/>
+    <p:sldId xmlns:r="http://schemas.openxmlformats.org/officeDocument/2006/relationships" id="268" r:id="R79c2a35a872f43d7"/>
+    <p:sldId xmlns:r="http://schemas.openxmlformats.org/officeDocument/2006/relationships" id="269" r:id="R6c11429ccd3c4395"/>
+    <p:sldId xmlns:r="http://schemas.openxmlformats.org/officeDocument/2006/relationships" id="270" r:id="R0794fa4e89034e82"/>
+    <p:sldId xmlns:r="http://schemas.openxmlformats.org/officeDocument/2006/relationships" id="271" r:id="R9c3f63089ab246e0"/>
+    <p:sldId xmlns:r="http://schemas.openxmlformats.org/officeDocument/2006/relationships" id="272" r:id="R1ddd2aa42e45494d"/>
+    <p:sldId xmlns:r="http://schemas.openxmlformats.org/officeDocument/2006/relationships" id="273" r:id="Rd2bd6c44440a4d77"/>
+    <p:sldId xmlns:r="http://schemas.openxmlformats.org/officeDocument/2006/relationships" id="274" r:id="Rdde938c2595d40b9"/>
+    <p:sldId xmlns:r="http://schemas.openxmlformats.org/officeDocument/2006/relationships" id="275" r:id="R7338004dfb9445dd"/>
+    <p:sldId xmlns:r="http://schemas.openxmlformats.org/officeDocument/2006/relationships" id="276" r:id="R2f26cd84dde04709"/>
+    <p:sldId xmlns:r="http://schemas.openxmlformats.org/officeDocument/2006/relationships" id="277" r:id="R5edfb8e965524a9d"/>
+    <p:sldId xmlns:r="http://schemas.openxmlformats.org/officeDocument/2006/relationships" id="278" r:id="Ra3b5b231b47a48d6"/>
+    <p:sldId xmlns:r="http://schemas.openxmlformats.org/officeDocument/2006/relationships" id="279" r:id="Reb2888fa52c3438b"/>
+    <p:sldId xmlns:r="http://schemas.openxmlformats.org/officeDocument/2006/relationships" id="280" r:id="R01174f01b9df4b88"/>
+    <p:sldId xmlns:r="http://schemas.openxmlformats.org/officeDocument/2006/relationships" id="281" r:id="R37bd2b7280fc4843"/>
+    <p:sldId xmlns:r="http://schemas.openxmlformats.org/officeDocument/2006/relationships" id="282" r:id="Reb7a6a209fef45eb"/>
+    <p:sldId xmlns:r="http://schemas.openxmlformats.org/officeDocument/2006/relationships" id="283" r:id="R1fde36c9f64e4dd8"/>
+    <p:sldId xmlns:r="http://schemas.openxmlformats.org/officeDocument/2006/relationships" id="284" r:id="R75bbfab782c049d3"/>
+    <p:sldId xmlns:r="http://schemas.openxmlformats.org/officeDocument/2006/relationships" id="285" r:id="Rc4339a527b254ecd"/>
+    <p:sldId xmlns:r="http://schemas.openxmlformats.org/officeDocument/2006/relationships" id="286" r:id="R0c6dd3c9df2d48c9"/>
   </p:sldIdLst>
   <p:sldSz cx="12192000" cy="6858000"/>
   <p:notesSz cx="6858000" cy="9144000"/>
@@ -625,7 +625,7 @@
           </a:p>
           <a:p xmlns:a="http://schemas.openxmlformats.org/drawingml/2006/main">
             <a:r>
-              <a:t>Welcome. Today each pair will write useful project instructions, change one request in a prepared program, and review an incorrect answer. We are following one canteen example. You do not need to learn every framework today.</a:t>
+              <a:t>Welcome. Plan for a possible 100-200 students, with actual attendance still to be confirmed. Each student records a useful instruction, a small code change and its result, and a review finding. Use your own laptop where available; sharing is optional. Explain that we will work together through common checkpoints. The presenter leads from the front; helpers, if available, handle individual laptop issues.</a:t>
             </a:r>
             <a:endParaRPr/>
           </a:p>
@@ -866,7 +866,7 @@
           </a:p>
           <a:p xmlns:a="http://schemas.openxmlformats.org/drawingml/2006/main">
             <a:r>
-              <a:t>Four minutes of actual student work. Each pair writes five instruction lines in a scratch file or on paper, then adds its best project-specific line to the supplied AGENTS.md. Do not replace existing instructions. Ask two pairs to read a line and explain how a reviewer could check it. If they are stuck, start with “Do not change menu records to make a test pass.”</a:t>
+              <a:t>Four-minute Checkpoint 1. Each student writes five useful instruction lines in their own scratch note or on paper, then adds the best line to supplied starter/AGENTS.md without removing existing guidance. Sharing a laptop is optional; each student records their own line and a way to check it. Ask for progress signals and sample two answers from different seating areas. Do not walk to every laptop. Example: do not change menu records to make a test pass.</a:t>
             </a:r>
           </a:p>
         </p:txBody>
@@ -1194,7 +1194,7 @@
           </a:p>
           <a:p xmlns:a="http://schemas.openxmlformats.org/drawingml/2006/main">
             <a:r>
-              <a:t>Run starter/agent.py --pause with Gemini only if tested beforehand; otherwise add --offline and explicitly disclose the rule-based stand-in. The pause reveals an already-completed trace. Ask for predictions, then reveal tool requests/results. A real model may group or reorder calls. Keep this demonstration to five minutes.</a:t>
+              <a:t>Five-minute instructor demonstration. Run starter/agent.py --pause with Gemini only if privately tested beforehand; otherwise add --offline and explicitly disclose the rule-based stand-in. The pause reveals an already-completed trace. Ask the whole room for predictions before each reveal. Students do not make simultaneous live calls. A real model may group or reorder requests.</a:t>
             </a:r>
             <a:endParaRPr/>
           </a:p>
@@ -1275,7 +1275,7 @@
           </a:p>
           <a:p xmlns:a="http://schemas.openxmlformats.org/drawingml/2006/main">
             <a:r>
-              <a:t>Eight minutes. Follow starter/README.md. Copy starter/agent.py to starter/practice_agent.py. Change only the first QUESTION budget from Rs 80 to Rs 30, manually or using a coding assistant. Do not change MENU_ONLY_QUESTION, tools or data. Run the copy with --offline. Compare before/after and explain why nothing qualifies. Advanced pairs try --scenario sold_out and --scenario menu_timeout. Check two pairs can explain the result before moving on. Finish by 12:00.</a:t>
+              <a:t>Eight-minute Checkpoint 2. First demonstrate copying starter/agent.py to starter/practice_agent.py and locating QUESTION. Everyone makes only the Rs 80 to Rs 30 change, manually or with an already configured coding assistant. Preserve MENU_ONLY_QUESTION, tools and data. Students run the copy with --offline and record the diff and observed result in their notes. Show the expected no-match result from the front. Use progress signals; helpers, if available, handle individual issues. Blocked students record a proposed edit and predicted output labelled not run, then continue. Optional sharing uses keyboard turns. Early finishers try sold_out or menu_timeout. Sample two explanations. Finish by 12:00.</a:t>
             </a:r>
           </a:p>
         </p:txBody>
@@ -1357,7 +1357,7 @@
           </a:p>
           <a:p xmlns:a="http://schemas.openxmlformats.org/drawingml/2006/main">
             <a:r>
-              <a:t>Five-minute break, 12:00–12:05. Return at 12:05. Open the review exercise and demo 04. If installation issues remain, use a working pair/paper route after the break.</a:t>
+              <a:t>Five-minute break, 12:00-12:05. Return at 12:05. Open docs/REVIEW.md and demo 04. Helpers may assist with unresolved setup during the break if available. The presenter does not promise to debug every laptop; blocked students continue with trace/source/paper after the break.</a:t>
             </a:r>
             <a:endParaRPr/>
           </a:p>
@@ -1520,7 +1520,7 @@
           </a:p>
           <a:p xmlns:a="http://schemas.openxmlformats.org/drawingml/2006/main">
             <a:r>
-              <a:t>Ask which facts the assistant needs: budget, diet, stock and hours. Take three answers. Students can use a laptop in pairs or follow on paper. Do not assume everyone completed the earlier workshop setup.</a:t>
+              <a:t>Ask which facts the assistant needs: budget, diet, stock and hours. Let everyone write a prediction first, then take two answers from different seating areas. Students can use their own laptop, share by taking turns, or record answers on paper. Do not assume everyone completed the earlier speaker setup.</a:t>
             </a:r>
             <a:endParaRPr/>
           </a:p>
@@ -1681,7 +1681,7 @@
           </a:p>
           <a:p xmlns:a="http://schemas.openxmlformats.org/drawingml/2006/main">
             <a:r>
-              <a:t>Six minutes. Use the one-page Review Exercise.pdf. Ask pairs to identify the unsafe return, describe a correcting change, and write one expected input/output check. Let them work before showing the worked answer. No API call or AI account is needed. Take two answers. A rule in AGENTS.md alone does not fix the program.</a:t>
+              <a:t>Six-minute Checkpoint 3. Open docs/REVIEW.md. Each student first identifies the unchecked return value, writes a correcting idea and one input/output check in their own note. Optional neighbour discussion follows. No Python or account is required. Ask for progress signals and sample two explanations. Demonstrate the worked answer afterward. A rule in AGENTS.md alone does not fix the unsafe return.</a:t>
             </a:r>
           </a:p>
         </p:txBody>
@@ -2009,7 +2009,7 @@
           </a:p>
           <a:p xmlns:a="http://schemas.openxmlformats.org/drawingml/2006/main">
             <a:r>
-              <a:t>Three minutes. Follow one normal route and one failed lookup route. Missing/invalid budget asks and ends this run; failure retries at most twice. No durable resumption is configured. Explicit graph structure can contain flexible agents. Ask which decision code should enforce.</a:t>
+              <a:t>Three minutes. Follow one normal route and one failed lookup route. Missing/invalid budget asks and ends this run. A failed menu lookup has two attempts total: one retry, then honest unavailable information. No durable resumption is configured. An explicit graph can contain flexible agents. Ask which decision code should enforce.</a:t>
             </a:r>
             <a:endParaRPr/>
           </a:p>
@@ -2255,7 +2255,7 @@
           </a:p>
           <a:p xmlns:a="http://schemas.openxmlformats.org/drawingml/2006/main">
             <a:r>
-              <a:t>Four minutes. One minute pair discussion: where would you allow a model to choose, and where should code check? Use menu filtering, campus helper and a paid order only as design questions. Take two answers. Extra jargon is not a better design. Finish by 12:40.</a:t>
+              <a:t>Four minutes. Give every student one minute to write where the model may choose and where code should check. Optional neighbour comparison follows; sample two answers from different seating areas. Use menu filtering, campus helper and a paid order as design questions. Extra jargon is not a better design. Finish by 12:40.</a:t>
             </a:r>
             <a:endParaRPr/>
           </a:p>
@@ -2418,7 +2418,7 @@
           </a:p>
           <a:p xmlns:a="http://schemas.openxmlformats.org/drawingml/2006/main">
             <a:r>
-              <a:t>Introduce Canteen Bhaiya and Overconfident AI briefly. Let pairs find the nonexistent wrap. This is a constructed bad answer, not a measured Gemini failure. Point out the real sandwich, sold-out poha, non-vegetarian chicken and over-budget dosa. Ask one student to explain the problem.</a:t>
+              <a:t>Introduce Canteen Bhaiya and Overconfident AI briefly. Give students thirty seconds to identify the nonexistent wrap, then sample answers. This is a constructed bad answer, not a measured Gemini failure. Point out the real sandwich, sold-out poha, non-vegetarian chicken and over-budget dosa.</a:t>
             </a:r>
             <a:endParaRPr/>
           </a:p>
@@ -2499,7 +2499,7 @@
           </a:p>
           <a:p xmlns:a="http://schemas.openxmlformats.org/drawingml/2006/main">
             <a:r>
-              <a:t>Six minutes. Each pair submits or shows: one useful instruction, the changed budget line with the resulting answer, and one review finding/check. Ask one first-year and one senior pair to explain in plain language. This is an exit check, not a promise everyone has mastered agents. If many are unsure, recap model/tool/code instead of introducing extra concepts.</a:t>
+              <a:t>Six-minute Checkpoint 4. Each student saves their own note: one useful instruction and how to check it, the budget diff and observed answer or clearly labelled unexecuted prediction, and one review finding/check. Ask for progress signals and sample explanations from different seating areas, including a beginner and a more experienced student where practical. Volunteers may spot-check within zones if available. No individual presenter approval queue. Use a collection channel only if already arranged by the coordinator. If many are unsure, recap model/tool/code and shorten extra framework discussion. Q&amp;A begins at 12:50.</a:t>
             </a:r>
           </a:p>
         </p:txBody>
@@ -2742,7 +2742,7 @@
           </a:p>
           <a:p xmlns:a="http://schemas.openxmlformats.org/drawingml/2006/main">
             <a:r>
-              <a:t>Four-minute demonstration, not a room-wide account troubleshooting exercise. Open AI Studio with a separate workshop account and show API Keys. New users may already have a default project/key. Otherwise create a key in the AI Studio interface. Check that the project/model has free-tier access. No Cloud Console provisioning, billing upgrade or credit purchase. Do not reveal a real key. Account access and quotas vary. Source: https://ai.google.dev/gemini-api/docs/api-key and https://ai.google.dev/gemini-api/docs/billing</a:t>
+              <a:t>Four-minute instructor demonstration, not simultaneous audience account creation. Open AI Studio and show API Keys using blank or masked configuration. New users may have a default project/key; otherwise show the creation route. Check free-tier/model access without promising eligibility or quota. Students continue with offline tasks and may configure live use privately outside the activity. No Cloud Console provisioning, billing upgrade or credit purchase. Sources: https://ai.google.dev/gemini-api/docs/api-key and https://ai.google.dev/gemini-api/docs/billing</a:t>
             </a:r>
           </a:p>
         </p:txBody>
@@ -2822,7 +2822,7 @@
           </a:p>
           <a:p xmlns:a="http://schemas.openxmlformats.org/drawingml/2006/main">
             <a:r>
-              <a:t>Show .env.example with a blank key on the projector. Explain that students privately copy their own key to .env as GOOGLE_API_KEY. Do not type, show or distribute your own key. A pre-recorded or masked demonstration is enough. Run check_setup.py privately before class; on stage only use a configured demo. Signing into Antigravity and configuring this API key are separate steps. If setup fails, continue with --offline. AI Studio is 18+; ineligible students use offline/paper. Sources: https://ai.google.dev/gemini-api/docs/api-key and https://ai.google.dev/gemini-api/docs/available-regions</a:t>
+              <a:t>Show starter/.env.example with a blank key. Explain private .env configuration as GOOGLE_API_KEY and the separate GEMINI_MODEL setting. Do not type, reveal or distribute a real key. Demonstrate with prepared or masked configuration, not a room-wide setup pause. Run starter/check_setup.py and the actual live agent privately before class if showing Gemini. Coding-assistant sign-in and this application key are separate. AI Studio is 18+; unavailable accounts continue offline. Sources: https://ai.google.dev/gemini-api/docs/api-key and https://ai.google.dev/gemini-api/docs/available-regions</a:t>
             </a:r>
           </a:p>
         </p:txBody>
@@ -2902,7 +2902,7 @@
           </a:p>
           <a:p xmlns:a="http://schemas.openxmlformats.org/drawingml/2006/main">
             <a:r>
-              <a:t>Three-minute checkpoint. Students should have installed dependencies before class. Open starter/README.md. From the repository root run starter/agent.py --offline. Explain that it is a rule-based stand-in using the real agent/tool plumbing, not a real AI. If a pair is blocked, pair them with a working laptop or use the printed trace. Do not spend the next section repairing installations.</a:t>
+              <a:t>Three-minute Checkpoint 0. Dependencies should already be installed. From the repository root run starter/agent.py --offline. Explicitly label the rule-based stand-in; the agent/tool plumbing still executes. Expected sandwich Rs 60 and closing time 16:00. Explain signals: 1 finger ready, 2 need help, 3 using saved trace. Helpers handle individual issues if available. Without helpers, address a repeated error briefly from the front and direct blocked students to deep-dives/demo/saved_runs/02_agent_lunch_and_hours_OFFLINE.txt, source and menu. Students record executed locally or read trace. Do not wait to inspect every laptop. Copy the supplied notes template or use paper.</a:t>
             </a:r>
           </a:p>
         </p:txBody>
@@ -3062,7 +3062,7 @@
           </a:p>
           <a:p xmlns:a="http://schemas.openxmlformats.org/drawingml/2006/main">
             <a:r>
-              <a:t>Three minutes. Type a title, a Requirements heading and two bullet points in a scratch Markdown file. Show preview. Add one fenced command example if the room is ready. Ask pairs to write one clear requirement. Avoid teaching Markdown extensions or front matter.</a:t>
+              <a:t>Three minutes. Type a title, a Requirements heading and two bullets in a scratch Markdown note. Show preview. Each student writes one clear requirement. Mention the starter/workshop_notes.template.md for recording checkpoint evidence. Avoid Markdown extensions and front matter.</a:t>
             </a:r>
           </a:p>
         </p:txBody>
@@ -3352,10 +3352,10 @@
   </p:cSld>
   <p:clrMap bg1="lt1" tx1="dk1" bg2="lt2" tx2="dk2" accent1="accent1" accent2="accent2" accent3="accent3" accent4="accent4" accent5="accent5" accent6="accent6" hlink="hlink" folHlink="folHlink"/>
   <p:sldLayoutIdLst>
-    <p:sldLayoutId xmlns:r="http://schemas.openxmlformats.org/officeDocument/2006/relationships" id="2147483649" r:id="R52047d91f7c44418"/>
-    <p:sldLayoutId xmlns:r="http://schemas.openxmlformats.org/officeDocument/2006/relationships" id="2147483650" r:id="Ra150ad7203c14132"/>
-    <p:sldLayoutId xmlns:r="http://schemas.openxmlformats.org/officeDocument/2006/relationships" id="2147483651" r:id="R703757d582e54371"/>
-    <p:sldLayoutId xmlns:r="http://schemas.openxmlformats.org/officeDocument/2006/relationships" id="2147483652" r:id="R1cdda83f075044ab"/>
+    <p:sldLayoutId xmlns:r="http://schemas.openxmlformats.org/officeDocument/2006/relationships" id="2147483649" r:id="R5d2893bac39a405d"/>
+    <p:sldLayoutId xmlns:r="http://schemas.openxmlformats.org/officeDocument/2006/relationships" id="2147483650" r:id="Re3a9c9d06d19484d"/>
+    <p:sldLayoutId xmlns:r="http://schemas.openxmlformats.org/officeDocument/2006/relationships" id="2147483651" r:id="R1c9fb5e8ff02421b"/>
+    <p:sldLayoutId xmlns:r="http://schemas.openxmlformats.org/officeDocument/2006/relationships" id="2147483652" r:id="Rf83041035f314ab0"/>
   </p:sldLayoutIdLst>
   <p:hf sldNum="0" hdr="0" ftr="0" dt="0"/>
   <p:txStyles>
@@ -4153,7 +4153,7 @@
           <p:cNvPr id="7" name="Image 0">
             <a:extLst xmlns:a="http://schemas.openxmlformats.org/drawingml/2006/main">
               <a:ext uri="{FF2B5EF4-FFF2-40B4-BE49-F238E27FC236}">
-                <a16:creationId xmlns:a16="http://schemas.microsoft.com/office/drawing/2014/main" id="{A2782C7B-C54B-438F-B67E-5D8CD5B6C10D}"/>
+                <a16:creationId xmlns:a16="http://schemas.microsoft.com/office/drawing/2014/main" id="{6ED012EB-401B-497F-BC08-9185E56BB75F}"/>
               </a:ext>
             </a:extLst>
           </p:cNvPr>
@@ -4163,7 +4163,7 @@
           <p:nvPr/>
         </p:nvPicPr>
         <p:blipFill>
-          <a:blip xmlns:r="http://schemas.openxmlformats.org/officeDocument/2006/relationships" xmlns:a="http://schemas.openxmlformats.org/drawingml/2006/main" r:embed="R2c678bd53a854956"/>
+          <a:blip xmlns:r="http://schemas.openxmlformats.org/officeDocument/2006/relationships" xmlns:a="http://schemas.openxmlformats.org/drawingml/2006/main" r:embed="Rd300a65d7b0e407b"/>
           <a:stretch xmlns:a="http://schemas.openxmlformats.org/drawingml/2006/main">
             <a:fillRect l="0" t="0" r="0" b="0"/>
           </a:stretch>
@@ -4216,7 +4216,7 @@
           <p:cNvPr id="9" name="Image 1">
             <a:extLst xmlns:a="http://schemas.openxmlformats.org/drawingml/2006/main">
               <a:ext uri="{FF2B5EF4-FFF2-40B4-BE49-F238E27FC236}">
-                <a16:creationId xmlns:a16="http://schemas.microsoft.com/office/drawing/2014/main" id="{02C0DB5C-5A18-41D1-8EB3-248BB6656B88}"/>
+                <a16:creationId xmlns:a16="http://schemas.microsoft.com/office/drawing/2014/main" id="{571E528E-6B67-4F86-B4E3-DE62B3F4A4AA}"/>
               </a:ext>
             </a:extLst>
           </p:cNvPr>
@@ -4226,7 +4226,7 @@
           <p:nvPr/>
         </p:nvPicPr>
         <p:blipFill>
-          <a:blip xmlns:r="http://schemas.openxmlformats.org/officeDocument/2006/relationships" xmlns:a="http://schemas.openxmlformats.org/drawingml/2006/main" r:embed="R9ea971a6910f40e0"/>
+          <a:blip xmlns:r="http://schemas.openxmlformats.org/officeDocument/2006/relationships" xmlns:a="http://schemas.openxmlformats.org/drawingml/2006/main" r:embed="R64ed50ed36904d78"/>
           <a:stretch xmlns:a="http://schemas.openxmlformats.org/drawingml/2006/main">
             <a:fillRect l="0" t="0" r="0" b="0"/>
           </a:stretch>
@@ -4275,7 +4275,7 @@
           <p:cNvPr id="11" name="lesson-title">
             <a:extLst xmlns:a="http://schemas.openxmlformats.org/drawingml/2006/main">
               <a:ext uri="{FF2B5EF4-FFF2-40B4-BE49-F238E27FC236}">
-                <a16:creationId xmlns:a16="http://schemas.microsoft.com/office/drawing/2014/main" id="{C9401DCE-FDC7-4039-8CCB-BD941E4CD419}"/>
+                <a16:creationId xmlns:a16="http://schemas.microsoft.com/office/drawing/2014/main" id="{98A46A6F-FB84-47A4-BFE6-C4324E33C656}"/>
               </a:ext>
             </a:extLst>
           </p:cNvPr>
@@ -4343,7 +4343,7 @@
           <p:cNvPr id="2" name="row-label-0">
             <a:extLst xmlns:a="http://schemas.openxmlformats.org/drawingml/2006/main">
               <a:ext uri="{FF2B5EF4-FFF2-40B4-BE49-F238E27FC236}">
-                <a16:creationId xmlns:a16="http://schemas.microsoft.com/office/drawing/2014/main" id="{2CC51617-F985-4A59-9DB3-06D551C7BB31}"/>
+                <a16:creationId xmlns:a16="http://schemas.microsoft.com/office/drawing/2014/main" id="{D36D3FD5-ED60-4AFE-AC01-022A2D49FE4D}"/>
               </a:ext>
             </a:extLst>
           </p:cNvPr>
@@ -4411,7 +4411,7 @@
           <p:cNvPr id="3" name="row-body-0">
             <a:extLst xmlns:a="http://schemas.openxmlformats.org/drawingml/2006/main">
               <a:ext uri="{FF2B5EF4-FFF2-40B4-BE49-F238E27FC236}">
-                <a16:creationId xmlns:a16="http://schemas.microsoft.com/office/drawing/2014/main" id="{4B9A176C-AEBD-4985-A87F-5F695FFEFC76}"/>
+                <a16:creationId xmlns:a16="http://schemas.microsoft.com/office/drawing/2014/main" id="{D3F11E3A-2F1C-4979-A6B0-FA89B4009238}"/>
               </a:ext>
             </a:extLst>
           </p:cNvPr>
@@ -4479,7 +4479,7 @@
           <p:cNvPr id="4" name="row-label-1">
             <a:extLst xmlns:a="http://schemas.openxmlformats.org/drawingml/2006/main">
               <a:ext uri="{FF2B5EF4-FFF2-40B4-BE49-F238E27FC236}">
-                <a16:creationId xmlns:a16="http://schemas.microsoft.com/office/drawing/2014/main" id="{A8D30D09-2E38-452E-963D-7AF0B7435A91}"/>
+                <a16:creationId xmlns:a16="http://schemas.microsoft.com/office/drawing/2014/main" id="{04922B27-9379-4D48-818D-04C87DE3F053}"/>
               </a:ext>
             </a:extLst>
           </p:cNvPr>
@@ -4547,7 +4547,7 @@
           <p:cNvPr id="5" name="row-body-1">
             <a:extLst xmlns:a="http://schemas.openxmlformats.org/drawingml/2006/main">
               <a:ext uri="{FF2B5EF4-FFF2-40B4-BE49-F238E27FC236}">
-                <a16:creationId xmlns:a16="http://schemas.microsoft.com/office/drawing/2014/main" id="{A62E2E17-B341-437E-882F-782D27F5BBF5}"/>
+                <a16:creationId xmlns:a16="http://schemas.microsoft.com/office/drawing/2014/main" id="{3E92BBD6-B4DD-454B-B827-BE3408D893AE}"/>
               </a:ext>
             </a:extLst>
           </p:cNvPr>
@@ -4615,7 +4615,7 @@
           <p:cNvPr id="6" name="row-label-2">
             <a:extLst xmlns:a="http://schemas.openxmlformats.org/drawingml/2006/main">
               <a:ext uri="{FF2B5EF4-FFF2-40B4-BE49-F238E27FC236}">
-                <a16:creationId xmlns:a16="http://schemas.microsoft.com/office/drawing/2014/main" id="{7AAC25BD-D62E-4FCF-9D46-61D20AB43147}"/>
+                <a16:creationId xmlns:a16="http://schemas.microsoft.com/office/drawing/2014/main" id="{43B5ABE7-57AB-42D8-9ACA-39211BF906FB}"/>
               </a:ext>
             </a:extLst>
           </p:cNvPr>
@@ -4683,7 +4683,7 @@
           <p:cNvPr id="7" name="row-body-2">
             <a:extLst xmlns:a="http://schemas.openxmlformats.org/drawingml/2006/main">
               <a:ext uri="{FF2B5EF4-FFF2-40B4-BE49-F238E27FC236}">
-                <a16:creationId xmlns:a16="http://schemas.microsoft.com/office/drawing/2014/main" id="{69FFB6EA-EA1D-40B0-BE57-0726F31E1ED7}"/>
+                <a16:creationId xmlns:a16="http://schemas.microsoft.com/office/drawing/2014/main" id="{8C9500E3-B536-4477-ACA3-03985B4B8F42}"/>
               </a:ext>
             </a:extLst>
           </p:cNvPr>
@@ -4751,7 +4751,7 @@
           <p:cNvPr id="8" name="takeaway">
             <a:extLst xmlns:a="http://schemas.openxmlformats.org/drawingml/2006/main">
               <a:ext uri="{FF2B5EF4-FFF2-40B4-BE49-F238E27FC236}">
-                <a16:creationId xmlns:a16="http://schemas.microsoft.com/office/drawing/2014/main" id="{0F03B6E2-9F2E-4037-B3E7-A1D91BD6E50C}"/>
+                <a16:creationId xmlns:a16="http://schemas.microsoft.com/office/drawing/2014/main" id="{4B8905C5-264E-435C-8C15-AED227BCE1C9}"/>
               </a:ext>
             </a:extLst>
           </p:cNvPr>
@@ -4819,7 +4819,7 @@
           <p:cNvPr id="9" name="footer">
             <a:extLst xmlns:a="http://schemas.openxmlformats.org/drawingml/2006/main">
               <a:ext uri="{FF2B5EF4-FFF2-40B4-BE49-F238E27FC236}">
-                <a16:creationId xmlns:a16="http://schemas.microsoft.com/office/drawing/2014/main" id="{31C36D74-3676-40DE-BF4B-264406C866DB}"/>
+                <a16:creationId xmlns:a16="http://schemas.microsoft.com/office/drawing/2014/main" id="{2DD4B341-D3A5-4069-ABEF-D345415B7A2C}"/>
               </a:ext>
             </a:extLst>
           </p:cNvPr>
@@ -4887,7 +4887,7 @@
           <p:cNvPr id="10" name="slide-number">
             <a:extLst xmlns:a="http://schemas.openxmlformats.org/drawingml/2006/main">
               <a:ext uri="{FF2B5EF4-FFF2-40B4-BE49-F238E27FC236}">
-                <a16:creationId xmlns:a16="http://schemas.microsoft.com/office/drawing/2014/main" id="{B6BB5E2A-6AD9-4D6B-8494-27C659C72EB7}"/>
+                <a16:creationId xmlns:a16="http://schemas.microsoft.com/office/drawing/2014/main" id="{A5980CE3-A6F6-47DF-8F01-75B3BCE1EF4A}"/>
               </a:ext>
             </a:extLst>
           </p:cNvPr>
@@ -4953,7 +4953,7 @@
     </p:spTree>
     <p:extLst>
       <p:ext uri="{BB962C8B-B14F-4D97-AF65-F5344CB8AC3E}">
-        <p14:creationId xmlns:p14="http://schemas.microsoft.com/office/powerpoint/2010/main" val="1554086762"/>
+        <p14:creationId xmlns:p14="http://schemas.microsoft.com/office/powerpoint/2010/main" val="1913027791"/>
       </p:ext>
     </p:extLst>
   </p:cSld>
@@ -4984,7 +4984,7 @@
           <p:cNvPr id="6" name="lesson-title">
             <a:extLst xmlns:a="http://schemas.openxmlformats.org/drawingml/2006/main">
               <a:ext uri="{FF2B5EF4-FFF2-40B4-BE49-F238E27FC236}">
-                <a16:creationId xmlns:a16="http://schemas.microsoft.com/office/drawing/2014/main" id="{3E96B64F-4FE3-451A-922A-1406EE30AD35}"/>
+                <a16:creationId xmlns:a16="http://schemas.microsoft.com/office/drawing/2014/main" id="{39C054EE-1893-49BE-A3CA-729AB0D42781}"/>
               </a:ext>
             </a:extLst>
           </p:cNvPr>
@@ -5052,7 +5052,7 @@
           <p:cNvPr id="2" name="code-example">
             <a:extLst xmlns:a="http://schemas.openxmlformats.org/drawingml/2006/main">
               <a:ext uri="{FF2B5EF4-FFF2-40B4-BE49-F238E27FC236}">
-                <a16:creationId xmlns:a16="http://schemas.microsoft.com/office/drawing/2014/main" id="{6D8EF716-DBDB-4BDF-B709-F8A82C4A4524}"/>
+                <a16:creationId xmlns:a16="http://schemas.microsoft.com/office/drawing/2014/main" id="{4B562619-A17F-40E4-AB61-EBF88215346A}"/>
               </a:ext>
             </a:extLst>
           </p:cNvPr>
@@ -5240,7 +5240,7 @@
           <p:cNvPr id="3" name="takeaway">
             <a:extLst xmlns:a="http://schemas.openxmlformats.org/drawingml/2006/main">
               <a:ext uri="{FF2B5EF4-FFF2-40B4-BE49-F238E27FC236}">
-                <a16:creationId xmlns:a16="http://schemas.microsoft.com/office/drawing/2014/main" id="{AD375D30-4DAF-44EB-B1BA-FC0F5C5CBE0C}"/>
+                <a16:creationId xmlns:a16="http://schemas.microsoft.com/office/drawing/2014/main" id="{2E4B1232-ACA4-4E12-BD75-C03EA4484555}"/>
               </a:ext>
             </a:extLst>
           </p:cNvPr>
@@ -5308,7 +5308,7 @@
           <p:cNvPr id="4" name="footer">
             <a:extLst xmlns:a="http://schemas.openxmlformats.org/drawingml/2006/main">
               <a:ext uri="{FF2B5EF4-FFF2-40B4-BE49-F238E27FC236}">
-                <a16:creationId xmlns:a16="http://schemas.microsoft.com/office/drawing/2014/main" id="{1B0FF2D6-57DC-4A7A-8D5E-9D820D2F64D6}"/>
+                <a16:creationId xmlns:a16="http://schemas.microsoft.com/office/drawing/2014/main" id="{26C9B7CC-8795-4A11-A4CE-36391A2F2024}"/>
               </a:ext>
             </a:extLst>
           </p:cNvPr>
@@ -5376,7 +5376,7 @@
           <p:cNvPr id="5" name="slide-number">
             <a:extLst xmlns:a="http://schemas.openxmlformats.org/drawingml/2006/main">
               <a:ext uri="{FF2B5EF4-FFF2-40B4-BE49-F238E27FC236}">
-                <a16:creationId xmlns:a16="http://schemas.microsoft.com/office/drawing/2014/main" id="{F1A83818-2E23-46EF-A976-3813FA436F02}"/>
+                <a16:creationId xmlns:a16="http://schemas.microsoft.com/office/drawing/2014/main" id="{BC91BA0C-D4C6-46D0-A4F1-29F0AAA52BDC}"/>
               </a:ext>
             </a:extLst>
           </p:cNvPr>
@@ -5442,7 +5442,7 @@
     </p:spTree>
     <p:extLst>
       <p:ext uri="{BB962C8B-B14F-4D97-AF65-F5344CB8AC3E}">
-        <p14:creationId xmlns:p14="http://schemas.microsoft.com/office/powerpoint/2010/main" val="961060768"/>
+        <p14:creationId xmlns:p14="http://schemas.microsoft.com/office/powerpoint/2010/main" val="1731224414"/>
       </p:ext>
     </p:extLst>
   </p:cSld>
@@ -5473,7 +5473,7 @@
           <p:cNvPr id="11" name="lesson-title">
             <a:extLst xmlns:a="http://schemas.openxmlformats.org/drawingml/2006/main">
               <a:ext uri="{FF2B5EF4-FFF2-40B4-BE49-F238E27FC236}">
-                <a16:creationId xmlns:a16="http://schemas.microsoft.com/office/drawing/2014/main" id="{233FC82A-D41F-45D2-8826-B716F07768C2}"/>
+                <a16:creationId xmlns:a16="http://schemas.microsoft.com/office/drawing/2014/main" id="{E4D52ACD-1809-4FFA-B21E-A9393B4B5109}"/>
               </a:ext>
             </a:extLst>
           </p:cNvPr>
@@ -5531,7 +5531,7 @@
                 <a:ea typeface="Bookman Old Style"/>
                 <a:cs typeface="Bookman Old Style"/>
               </a:rPr>
-              <a:t>Pair task: write five useful lines</a:t>
+              <a:t>Checkpoint 1: useful instructions</a:t>
             </a:r>
           </a:p>
         </p:txBody>
@@ -5541,7 +5541,7 @@
           <p:cNvPr id="2" name="row-label-0">
             <a:extLst xmlns:a="http://schemas.openxmlformats.org/drawingml/2006/main">
               <a:ext uri="{FF2B5EF4-FFF2-40B4-BE49-F238E27FC236}">
-                <a16:creationId xmlns:a16="http://schemas.microsoft.com/office/drawing/2014/main" id="{31F3AC44-C4A4-4C0C-9C10-34E022B91711}"/>
+                <a16:creationId xmlns:a16="http://schemas.microsoft.com/office/drawing/2014/main" id="{B8AD93B5-A55F-4CA8-A991-17E231A66861}"/>
               </a:ext>
             </a:extLst>
           </p:cNvPr>
@@ -5609,7 +5609,7 @@
           <p:cNvPr id="3" name="row-body-0">
             <a:extLst xmlns:a="http://schemas.openxmlformats.org/drawingml/2006/main">
               <a:ext uri="{FF2B5EF4-FFF2-40B4-BE49-F238E27FC236}">
-                <a16:creationId xmlns:a16="http://schemas.microsoft.com/office/drawing/2014/main" id="{F1FE374F-8BE2-482E-A9E2-5ACE05E269EA}"/>
+                <a16:creationId xmlns:a16="http://schemas.microsoft.com/office/drawing/2014/main" id="{65B08D0C-E769-443E-B4E6-1C600F47D528}"/>
               </a:ext>
             </a:extLst>
           </p:cNvPr>
@@ -5677,7 +5677,7 @@
           <p:cNvPr id="4" name="row-label-1">
             <a:extLst xmlns:a="http://schemas.openxmlformats.org/drawingml/2006/main">
               <a:ext uri="{FF2B5EF4-FFF2-40B4-BE49-F238E27FC236}">
-                <a16:creationId xmlns:a16="http://schemas.microsoft.com/office/drawing/2014/main" id="{3A79356E-9327-4B23-ABAB-4E3D7848BE96}"/>
+                <a16:creationId xmlns:a16="http://schemas.microsoft.com/office/drawing/2014/main" id="{B5EAB728-CFA7-480C-8F4A-A734FFD4DF6C}"/>
               </a:ext>
             </a:extLst>
           </p:cNvPr>
@@ -5745,7 +5745,7 @@
           <p:cNvPr id="5" name="row-body-1">
             <a:extLst xmlns:a="http://schemas.openxmlformats.org/drawingml/2006/main">
               <a:ext uri="{FF2B5EF4-FFF2-40B4-BE49-F238E27FC236}">
-                <a16:creationId xmlns:a16="http://schemas.microsoft.com/office/drawing/2014/main" id="{9619D756-447D-41E3-B41F-4C4465EE96B9}"/>
+                <a16:creationId xmlns:a16="http://schemas.microsoft.com/office/drawing/2014/main" id="{651F27FB-3E1B-41E4-BE9D-F97528CF3B2C}"/>
               </a:ext>
             </a:extLst>
           </p:cNvPr>
@@ -5813,7 +5813,7 @@
           <p:cNvPr id="6" name="row-label-2">
             <a:extLst xmlns:a="http://schemas.openxmlformats.org/drawingml/2006/main">
               <a:ext uri="{FF2B5EF4-FFF2-40B4-BE49-F238E27FC236}">
-                <a16:creationId xmlns:a16="http://schemas.microsoft.com/office/drawing/2014/main" id="{DDBB08F7-3C8B-47C0-9C64-99C63017A8F8}"/>
+                <a16:creationId xmlns:a16="http://schemas.microsoft.com/office/drawing/2014/main" id="{9BA1446A-520F-4AAE-9040-AA389D892383}"/>
               </a:ext>
             </a:extLst>
           </p:cNvPr>
@@ -5881,7 +5881,7 @@
           <p:cNvPr id="7" name="row-body-2">
             <a:extLst xmlns:a="http://schemas.openxmlformats.org/drawingml/2006/main">
               <a:ext uri="{FF2B5EF4-FFF2-40B4-BE49-F238E27FC236}">
-                <a16:creationId xmlns:a16="http://schemas.microsoft.com/office/drawing/2014/main" id="{E2CF6637-BD13-460C-94A8-FB3429D85C9F}"/>
+                <a16:creationId xmlns:a16="http://schemas.microsoft.com/office/drawing/2014/main" id="{8203F330-2D52-4A0F-83E5-AEBE554B37B4}"/>
               </a:ext>
             </a:extLst>
           </p:cNvPr>
@@ -5949,7 +5949,7 @@
           <p:cNvPr id="8" name="takeaway">
             <a:extLst xmlns:a="http://schemas.openxmlformats.org/drawingml/2006/main">
               <a:ext uri="{FF2B5EF4-FFF2-40B4-BE49-F238E27FC236}">
-                <a16:creationId xmlns:a16="http://schemas.microsoft.com/office/drawing/2014/main" id="{B6AB1275-2E47-4301-9C43-DA5C417A5865}"/>
+                <a16:creationId xmlns:a16="http://schemas.microsoft.com/office/drawing/2014/main" id="{F99FF36C-9678-4B68-8C76-09BA767DF58F}"/>
               </a:ext>
             </a:extLst>
           </p:cNvPr>
@@ -6007,7 +6007,7 @@
                 <a:ea typeface="Calibri"/>
                 <a:cs typeface="Calibri"/>
               </a:rPr>
-              <a:t>Share your most useful instruction with a partner.</a:t>
+              <a:t>Record your own instruction and how someone can check it.</a:t>
             </a:r>
           </a:p>
         </p:txBody>
@@ -6017,7 +6017,7 @@
           <p:cNvPr id="9" name="footer">
             <a:extLst xmlns:a="http://schemas.openxmlformats.org/drawingml/2006/main">
               <a:ext uri="{FF2B5EF4-FFF2-40B4-BE49-F238E27FC236}">
-                <a16:creationId xmlns:a16="http://schemas.microsoft.com/office/drawing/2014/main" id="{957BCC79-D72F-45CA-ABB7-09FBCE330351}"/>
+                <a16:creationId xmlns:a16="http://schemas.microsoft.com/office/drawing/2014/main" id="{43436D57-10DF-447E-8B51-05FE01321834}"/>
               </a:ext>
             </a:extLst>
           </p:cNvPr>
@@ -6085,7 +6085,7 @@
           <p:cNvPr id="10" name="slide-number">
             <a:extLst xmlns:a="http://schemas.openxmlformats.org/drawingml/2006/main">
               <a:ext uri="{FF2B5EF4-FFF2-40B4-BE49-F238E27FC236}">
-                <a16:creationId xmlns:a16="http://schemas.microsoft.com/office/drawing/2014/main" id="{6A330297-1C38-4F5A-8650-E2110133705D}"/>
+                <a16:creationId xmlns:a16="http://schemas.microsoft.com/office/drawing/2014/main" id="{DDFA2F8F-6167-4B3F-A91E-C149545C2320}"/>
               </a:ext>
             </a:extLst>
           </p:cNvPr>
@@ -6151,7 +6151,7 @@
     </p:spTree>
     <p:extLst>
       <p:ext uri="{BB962C8B-B14F-4D97-AF65-F5344CB8AC3E}">
-        <p14:creationId xmlns:p14="http://schemas.microsoft.com/office/powerpoint/2010/main" val="325323756"/>
+        <p14:creationId xmlns:p14="http://schemas.microsoft.com/office/powerpoint/2010/main" val="1052043094"/>
       </p:ext>
     </p:extLst>
   </p:cSld>
@@ -6182,7 +6182,7 @@
           <p:cNvPr id="6" name="lesson-title">
             <a:extLst xmlns:a="http://schemas.openxmlformats.org/drawingml/2006/main">
               <a:ext uri="{FF2B5EF4-FFF2-40B4-BE49-F238E27FC236}">
-                <a16:creationId xmlns:a16="http://schemas.microsoft.com/office/drawing/2014/main" id="{610C4CD1-5F37-4776-9B57-E184A29BFD85}"/>
+                <a16:creationId xmlns:a16="http://schemas.microsoft.com/office/drawing/2014/main" id="{CDB6447F-A104-4157-A668-0ECE19378ECB}"/>
               </a:ext>
             </a:extLst>
           </p:cNvPr>
@@ -6250,7 +6250,7 @@
           <p:cNvPr id="2" name="code-example">
             <a:extLst xmlns:a="http://schemas.openxmlformats.org/drawingml/2006/main">
               <a:ext uri="{FF2B5EF4-FFF2-40B4-BE49-F238E27FC236}">
-                <a16:creationId xmlns:a16="http://schemas.microsoft.com/office/drawing/2014/main" id="{DC98AB07-C0FD-4675-9A11-DB2F52670D19}"/>
+                <a16:creationId xmlns:a16="http://schemas.microsoft.com/office/drawing/2014/main" id="{81BB37AF-81C8-4CC9-8630-A2D330EC7B74}"/>
               </a:ext>
             </a:extLst>
           </p:cNvPr>
@@ -6433,7 +6433,7 @@
           <p:cNvPr id="3" name="takeaway">
             <a:extLst xmlns:a="http://schemas.openxmlformats.org/drawingml/2006/main">
               <a:ext uri="{FF2B5EF4-FFF2-40B4-BE49-F238E27FC236}">
-                <a16:creationId xmlns:a16="http://schemas.microsoft.com/office/drawing/2014/main" id="{48EDB81F-4F33-4B91-8282-9B01DE31FFFA}"/>
+                <a16:creationId xmlns:a16="http://schemas.microsoft.com/office/drawing/2014/main" id="{D722A641-F25E-4776-A819-0E5959F84DA1}"/>
               </a:ext>
             </a:extLst>
           </p:cNvPr>
@@ -6501,7 +6501,7 @@
           <p:cNvPr id="4" name="footer">
             <a:extLst xmlns:a="http://schemas.openxmlformats.org/drawingml/2006/main">
               <a:ext uri="{FF2B5EF4-FFF2-40B4-BE49-F238E27FC236}">
-                <a16:creationId xmlns:a16="http://schemas.microsoft.com/office/drawing/2014/main" id="{E3B0DEE5-16A6-42AE-88B5-C34793105144}"/>
+                <a16:creationId xmlns:a16="http://schemas.microsoft.com/office/drawing/2014/main" id="{87F9D949-FDF2-47DB-9DBF-277B21298650}"/>
               </a:ext>
             </a:extLst>
           </p:cNvPr>
@@ -6569,7 +6569,7 @@
           <p:cNvPr id="5" name="slide-number">
             <a:extLst xmlns:a="http://schemas.openxmlformats.org/drawingml/2006/main">
               <a:ext uri="{FF2B5EF4-FFF2-40B4-BE49-F238E27FC236}">
-                <a16:creationId xmlns:a16="http://schemas.microsoft.com/office/drawing/2014/main" id="{AEDF7870-6C73-4490-A919-AB9C466DF179}"/>
+                <a16:creationId xmlns:a16="http://schemas.microsoft.com/office/drawing/2014/main" id="{0DD9F32C-5EE5-4D55-BB1C-D612E07A0C26}"/>
               </a:ext>
             </a:extLst>
           </p:cNvPr>
@@ -6635,7 +6635,7 @@
     </p:spTree>
     <p:extLst>
       <p:ext uri="{BB962C8B-B14F-4D97-AF65-F5344CB8AC3E}">
-        <p14:creationId xmlns:p14="http://schemas.microsoft.com/office/powerpoint/2010/main" val="1778142598"/>
+        <p14:creationId xmlns:p14="http://schemas.microsoft.com/office/powerpoint/2010/main" val="1471361563"/>
       </p:ext>
     </p:extLst>
   </p:cSld>
@@ -8183,7 +8183,7 @@
           <p:cNvPr id="11" name="lesson-title">
             <a:extLst xmlns:a="http://schemas.openxmlformats.org/drawingml/2006/main">
               <a:ext uri="{FF2B5EF4-FFF2-40B4-BE49-F238E27FC236}">
-                <a16:creationId xmlns:a16="http://schemas.microsoft.com/office/drawing/2014/main" id="{310D5820-A21F-4AAF-96E2-CACCE988AE44}"/>
+                <a16:creationId xmlns:a16="http://schemas.microsoft.com/office/drawing/2014/main" id="{2432BE61-6728-4946-9F15-51D25AC079C7}"/>
               </a:ext>
             </a:extLst>
           </p:cNvPr>
@@ -8241,7 +8241,7 @@
                 <a:ea typeface="Bookman Old Style"/>
                 <a:cs typeface="Bookman Old Style"/>
               </a:rPr>
-              <a:t>Pair task: make one small code change</a:t>
+              <a:t>Checkpoint 2: change and run</a:t>
             </a:r>
           </a:p>
         </p:txBody>
@@ -8251,7 +8251,7 @@
           <p:cNvPr id="2" name="row-label-0">
             <a:extLst xmlns:a="http://schemas.openxmlformats.org/drawingml/2006/main">
               <a:ext uri="{FF2B5EF4-FFF2-40B4-BE49-F238E27FC236}">
-                <a16:creationId xmlns:a16="http://schemas.microsoft.com/office/drawing/2014/main" id="{0E1DA9F4-D881-42CC-97EB-D334739FFFBE}"/>
+                <a16:creationId xmlns:a16="http://schemas.microsoft.com/office/drawing/2014/main" id="{3480792F-7EA8-449D-993E-022C7153FF68}"/>
               </a:ext>
             </a:extLst>
           </p:cNvPr>
@@ -8319,7 +8319,7 @@
           <p:cNvPr id="3" name="row-body-0">
             <a:extLst xmlns:a="http://schemas.openxmlformats.org/drawingml/2006/main">
               <a:ext uri="{FF2B5EF4-FFF2-40B4-BE49-F238E27FC236}">
-                <a16:creationId xmlns:a16="http://schemas.microsoft.com/office/drawing/2014/main" id="{BF6271E9-63D9-4EDB-9A06-7F470BE6B9C9}"/>
+                <a16:creationId xmlns:a16="http://schemas.microsoft.com/office/drawing/2014/main" id="{F052FF4C-7420-4473-BC57-9F5C3D8B3927}"/>
               </a:ext>
             </a:extLst>
           </p:cNvPr>
@@ -8387,7 +8387,7 @@
           <p:cNvPr id="4" name="row-label-1">
             <a:extLst xmlns:a="http://schemas.openxmlformats.org/drawingml/2006/main">
               <a:ext uri="{FF2B5EF4-FFF2-40B4-BE49-F238E27FC236}">
-                <a16:creationId xmlns:a16="http://schemas.microsoft.com/office/drawing/2014/main" id="{6409DA3A-43AE-4793-9543-F70026EB8016}"/>
+                <a16:creationId xmlns:a16="http://schemas.microsoft.com/office/drawing/2014/main" id="{7EEDBA64-ED3F-4987-8F76-8ECF084DA7B9}"/>
               </a:ext>
             </a:extLst>
           </p:cNvPr>
@@ -8455,7 +8455,7 @@
           <p:cNvPr id="5" name="row-body-1">
             <a:extLst xmlns:a="http://schemas.openxmlformats.org/drawingml/2006/main">
               <a:ext uri="{FF2B5EF4-FFF2-40B4-BE49-F238E27FC236}">
-                <a16:creationId xmlns:a16="http://schemas.microsoft.com/office/drawing/2014/main" id="{AC7FA336-3541-4394-81E1-A88CCA0C0F91}"/>
+                <a16:creationId xmlns:a16="http://schemas.microsoft.com/office/drawing/2014/main" id="{0E88194B-ABD8-46DC-BC72-3C5E342DFE3E}"/>
               </a:ext>
             </a:extLst>
           </p:cNvPr>
@@ -8523,7 +8523,7 @@
           <p:cNvPr id="6" name="row-label-2">
             <a:extLst xmlns:a="http://schemas.openxmlformats.org/drawingml/2006/main">
               <a:ext uri="{FF2B5EF4-FFF2-40B4-BE49-F238E27FC236}">
-                <a16:creationId xmlns:a16="http://schemas.microsoft.com/office/drawing/2014/main" id="{7261AFB0-20B6-4803-82F4-B4CA7E8BD876}"/>
+                <a16:creationId xmlns:a16="http://schemas.microsoft.com/office/drawing/2014/main" id="{D396BF1D-6B45-4B04-A9E3-55EEDEBF786D}"/>
               </a:ext>
             </a:extLst>
           </p:cNvPr>
@@ -8591,7 +8591,7 @@
           <p:cNvPr id="7" name="row-body-2">
             <a:extLst xmlns:a="http://schemas.openxmlformats.org/drawingml/2006/main">
               <a:ext uri="{FF2B5EF4-FFF2-40B4-BE49-F238E27FC236}">
-                <a16:creationId xmlns:a16="http://schemas.microsoft.com/office/drawing/2014/main" id="{435CAA5D-A2C6-447E-9AD3-CE7B3D79920B}"/>
+                <a16:creationId xmlns:a16="http://schemas.microsoft.com/office/drawing/2014/main" id="{348209F5-139C-4796-B47E-D78A814C8C08}"/>
               </a:ext>
             </a:extLst>
           </p:cNvPr>
@@ -8659,7 +8659,7 @@
           <p:cNvPr id="8" name="takeaway">
             <a:extLst xmlns:a="http://schemas.openxmlformats.org/drawingml/2006/main">
               <a:ext uri="{FF2B5EF4-FFF2-40B4-BE49-F238E27FC236}">
-                <a16:creationId xmlns:a16="http://schemas.microsoft.com/office/drawing/2014/main" id="{6965A122-ACE2-4643-850D-CB4C3AFF8DC2}"/>
+                <a16:creationId xmlns:a16="http://schemas.microsoft.com/office/drawing/2014/main" id="{271257D9-9BEF-4F70-BB3C-6440B0E701B2}"/>
               </a:ext>
             </a:extLst>
           </p:cNvPr>
@@ -8717,7 +8717,7 @@
                 <a:ea typeface="Calibri"/>
                 <a:cs typeface="Calibri"/>
               </a:rPr>
-              <a:t>Read the diff before running an AI-generated edit.</a:t>
+              <a:t>Record the changed line and the result you actually observed.</a:t>
             </a:r>
           </a:p>
         </p:txBody>
@@ -8727,7 +8727,7 @@
           <p:cNvPr id="9" name="footer">
             <a:extLst xmlns:a="http://schemas.openxmlformats.org/drawingml/2006/main">
               <a:ext uri="{FF2B5EF4-FFF2-40B4-BE49-F238E27FC236}">
-                <a16:creationId xmlns:a16="http://schemas.microsoft.com/office/drawing/2014/main" id="{1E814BBB-567D-41DC-B47A-0CE3CA1615C3}"/>
+                <a16:creationId xmlns:a16="http://schemas.microsoft.com/office/drawing/2014/main" id="{9DC65A67-67A3-4834-A9F6-70011D7E33B1}"/>
               </a:ext>
             </a:extLst>
           </p:cNvPr>
@@ -8795,7 +8795,7 @@
           <p:cNvPr id="10" name="slide-number">
             <a:extLst xmlns:a="http://schemas.openxmlformats.org/drawingml/2006/main">
               <a:ext uri="{FF2B5EF4-FFF2-40B4-BE49-F238E27FC236}">
-                <a16:creationId xmlns:a16="http://schemas.microsoft.com/office/drawing/2014/main" id="{A5B7FD0E-7E44-465B-91FB-3440EFA2571C}"/>
+                <a16:creationId xmlns:a16="http://schemas.microsoft.com/office/drawing/2014/main" id="{3459DBB1-B755-4FA3-A296-413DAF5C9E7E}"/>
               </a:ext>
             </a:extLst>
           </p:cNvPr>
@@ -8861,7 +8861,7 @@
     </p:spTree>
     <p:extLst>
       <p:ext uri="{BB962C8B-B14F-4D97-AF65-F5344CB8AC3E}">
-        <p14:creationId xmlns:p14="http://schemas.microsoft.com/office/powerpoint/2010/main" val="568626358"/>
+        <p14:creationId xmlns:p14="http://schemas.microsoft.com/office/powerpoint/2010/main" val="1232074816"/>
       </p:ext>
     </p:extLst>
   </p:cSld>
@@ -10568,7 +10568,7 @@
           <p:cNvPr id="6" name="lesson-title">
             <a:extLst xmlns:a="http://schemas.openxmlformats.org/drawingml/2006/main">
               <a:ext uri="{FF2B5EF4-FFF2-40B4-BE49-F238E27FC236}">
-                <a16:creationId xmlns:a16="http://schemas.microsoft.com/office/drawing/2014/main" id="{97CA3D0E-A241-410E-B75E-4609364C8715}"/>
+                <a16:creationId xmlns:a16="http://schemas.microsoft.com/office/drawing/2014/main" id="{27171098-1B57-4DBA-9BB1-AD28AEF54849}"/>
               </a:ext>
             </a:extLst>
           </p:cNvPr>
@@ -10626,7 +10626,7 @@
                 <a:ea typeface="Bookman Old Style"/>
                 <a:cs typeface="Bookman Old Style"/>
               </a:rPr>
-              <a:t>Pair review: find the unchecked value</a:t>
+              <a:t>Checkpoint 3: review the answer</a:t>
             </a:r>
           </a:p>
         </p:txBody>
@@ -10636,7 +10636,7 @@
           <p:cNvPr id="2" name="code-example">
             <a:extLst xmlns:a="http://schemas.openxmlformats.org/drawingml/2006/main">
               <a:ext uri="{FF2B5EF4-FFF2-40B4-BE49-F238E27FC236}">
-                <a16:creationId xmlns:a16="http://schemas.microsoft.com/office/drawing/2014/main" id="{6AFA0C85-BEE0-486B-B092-A97154366552}"/>
+                <a16:creationId xmlns:a16="http://schemas.microsoft.com/office/drawing/2014/main" id="{E9D5A54A-E082-44F5-A5A4-E865CF522D2C}"/>
               </a:ext>
             </a:extLst>
           </p:cNvPr>
@@ -10755,7 +10755,7 @@
           <p:cNvPr id="3" name="takeaway">
             <a:extLst xmlns:a="http://schemas.openxmlformats.org/drawingml/2006/main">
               <a:ext uri="{FF2B5EF4-FFF2-40B4-BE49-F238E27FC236}">
-                <a16:creationId xmlns:a16="http://schemas.microsoft.com/office/drawing/2014/main" id="{E935A49B-23F6-4769-883B-23EFC5817EA9}"/>
+                <a16:creationId xmlns:a16="http://schemas.microsoft.com/office/drawing/2014/main" id="{8F375127-F6E3-4A81-9E03-C3E9B3CE9E1E}"/>
               </a:ext>
             </a:extLst>
           </p:cNvPr>
@@ -10813,7 +10813,7 @@
                 <a:ea typeface="Calibri"/>
                 <a:cs typeface="Calibri"/>
               </a:rPr>
-              <a:t>What exact value reaches the student?</a:t>
+              <a:t>Record the unchecked value and one check that catches it.</a:t>
             </a:r>
           </a:p>
         </p:txBody>
@@ -10823,7 +10823,7 @@
           <p:cNvPr id="4" name="footer">
             <a:extLst xmlns:a="http://schemas.openxmlformats.org/drawingml/2006/main">
               <a:ext uri="{FF2B5EF4-FFF2-40B4-BE49-F238E27FC236}">
-                <a16:creationId xmlns:a16="http://schemas.microsoft.com/office/drawing/2014/main" id="{BF0F2EFB-374C-4DFA-A2B8-37117B6EBD77}"/>
+                <a16:creationId xmlns:a16="http://schemas.microsoft.com/office/drawing/2014/main" id="{4E7AC003-4B4B-45FD-9202-E5E45414FACF}"/>
               </a:ext>
             </a:extLst>
           </p:cNvPr>
@@ -10891,7 +10891,7 @@
           <p:cNvPr id="5" name="slide-number">
             <a:extLst xmlns:a="http://schemas.openxmlformats.org/drawingml/2006/main">
               <a:ext uri="{FF2B5EF4-FFF2-40B4-BE49-F238E27FC236}">
-                <a16:creationId xmlns:a16="http://schemas.microsoft.com/office/drawing/2014/main" id="{9194093D-8771-4B12-A84E-7CB2A9E639BC}"/>
+                <a16:creationId xmlns:a16="http://schemas.microsoft.com/office/drawing/2014/main" id="{1EFD88BB-F70E-49F2-BA69-517B2B2D3908}"/>
               </a:ext>
             </a:extLst>
           </p:cNvPr>
@@ -10957,7 +10957,7 @@
     </p:spTree>
     <p:extLst>
       <p:ext uri="{BB962C8B-B14F-4D97-AF65-F5344CB8AC3E}">
-        <p14:creationId xmlns:p14="http://schemas.microsoft.com/office/powerpoint/2010/main" val="437748387"/>
+        <p14:creationId xmlns:p14="http://schemas.microsoft.com/office/powerpoint/2010/main" val="944673100"/>
       </p:ext>
     </p:extLst>
   </p:cSld>
@@ -11902,7 +11902,7 @@
           <p:cNvPr id="11" name="lesson-title">
             <a:extLst xmlns:a="http://schemas.openxmlformats.org/drawingml/2006/main">
               <a:ext uri="{FF2B5EF4-FFF2-40B4-BE49-F238E27FC236}">
-                <a16:creationId xmlns:a16="http://schemas.microsoft.com/office/drawing/2014/main" id="{E96495CE-BF05-4C25-A8E3-E4009D2DE292}"/>
+                <a16:creationId xmlns:a16="http://schemas.microsoft.com/office/drawing/2014/main" id="{36F5FD22-1911-4BCF-A620-806ADF84DE4C}"/>
               </a:ext>
             </a:extLst>
           </p:cNvPr>
@@ -11970,7 +11970,7 @@
           <p:cNvPr id="2" name="row-label-0">
             <a:extLst xmlns:a="http://schemas.openxmlformats.org/drawingml/2006/main">
               <a:ext uri="{FF2B5EF4-FFF2-40B4-BE49-F238E27FC236}">
-                <a16:creationId xmlns:a16="http://schemas.microsoft.com/office/drawing/2014/main" id="{70AF2F11-7CBD-4A52-8603-FC3FC04FF2C3}"/>
+                <a16:creationId xmlns:a16="http://schemas.microsoft.com/office/drawing/2014/main" id="{490661DA-F801-4D6E-87A3-A13FDF4C3ACC}"/>
               </a:ext>
             </a:extLst>
           </p:cNvPr>
@@ -12038,7 +12038,7 @@
           <p:cNvPr id="3" name="row-body-0">
             <a:extLst xmlns:a="http://schemas.openxmlformats.org/drawingml/2006/main">
               <a:ext uri="{FF2B5EF4-FFF2-40B4-BE49-F238E27FC236}">
-                <a16:creationId xmlns:a16="http://schemas.microsoft.com/office/drawing/2014/main" id="{91A6FFD0-314D-4F93-9417-FDB4E09C9A61}"/>
+                <a16:creationId xmlns:a16="http://schemas.microsoft.com/office/drawing/2014/main" id="{33BB9924-8771-4FC0-BF61-5B1CA513887D}"/>
               </a:ext>
             </a:extLst>
           </p:cNvPr>
@@ -12106,7 +12106,7 @@
           <p:cNvPr id="4" name="row-label-1">
             <a:extLst xmlns:a="http://schemas.openxmlformats.org/drawingml/2006/main">
               <a:ext uri="{FF2B5EF4-FFF2-40B4-BE49-F238E27FC236}">
-                <a16:creationId xmlns:a16="http://schemas.microsoft.com/office/drawing/2014/main" id="{EAF25824-AEFD-4CEB-AA59-1644BE7DDAC1}"/>
+                <a16:creationId xmlns:a16="http://schemas.microsoft.com/office/drawing/2014/main" id="{A51E1C7B-F987-40E4-A178-6BC56841F876}"/>
               </a:ext>
             </a:extLst>
           </p:cNvPr>
@@ -12174,7 +12174,7 @@
           <p:cNvPr id="5" name="row-body-1">
             <a:extLst xmlns:a="http://schemas.openxmlformats.org/drawingml/2006/main">
               <a:ext uri="{FF2B5EF4-FFF2-40B4-BE49-F238E27FC236}">
-                <a16:creationId xmlns:a16="http://schemas.microsoft.com/office/drawing/2014/main" id="{2F34DA67-8DEE-4843-87A4-E9CA186CE3CC}"/>
+                <a16:creationId xmlns:a16="http://schemas.microsoft.com/office/drawing/2014/main" id="{81D2C271-F5E4-48A3-8B6B-1E64B6B045F7}"/>
               </a:ext>
             </a:extLst>
           </p:cNvPr>
@@ -12242,7 +12242,7 @@
           <p:cNvPr id="6" name="row-label-2">
             <a:extLst xmlns:a="http://schemas.openxmlformats.org/drawingml/2006/main">
               <a:ext uri="{FF2B5EF4-FFF2-40B4-BE49-F238E27FC236}">
-                <a16:creationId xmlns:a16="http://schemas.microsoft.com/office/drawing/2014/main" id="{6F994CC1-26C9-45B9-A028-61395AA2F175}"/>
+                <a16:creationId xmlns:a16="http://schemas.microsoft.com/office/drawing/2014/main" id="{4F013229-2481-4F33-AAA6-449212017F3D}"/>
               </a:ext>
             </a:extLst>
           </p:cNvPr>
@@ -12310,7 +12310,7 @@
           <p:cNvPr id="7" name="row-body-2">
             <a:extLst xmlns:a="http://schemas.openxmlformats.org/drawingml/2006/main">
               <a:ext uri="{FF2B5EF4-FFF2-40B4-BE49-F238E27FC236}">
-                <a16:creationId xmlns:a16="http://schemas.microsoft.com/office/drawing/2014/main" id="{890E1316-71B6-4EF6-9153-C7D21972FA05}"/>
+                <a16:creationId xmlns:a16="http://schemas.microsoft.com/office/drawing/2014/main" id="{6C93B813-F18B-4808-B713-6264EE91BCED}"/>
               </a:ext>
             </a:extLst>
           </p:cNvPr>
@@ -12378,7 +12378,7 @@
           <p:cNvPr id="8" name="takeaway">
             <a:extLst xmlns:a="http://schemas.openxmlformats.org/drawingml/2006/main">
               <a:ext uri="{FF2B5EF4-FFF2-40B4-BE49-F238E27FC236}">
-                <a16:creationId xmlns:a16="http://schemas.microsoft.com/office/drawing/2014/main" id="{431E48AC-0621-46B6-8850-A74BA5307024}"/>
+                <a16:creationId xmlns:a16="http://schemas.microsoft.com/office/drawing/2014/main" id="{49F15355-399D-486C-99FC-18EBD5B8E12A}"/>
               </a:ext>
             </a:extLst>
           </p:cNvPr>
@@ -12446,7 +12446,7 @@
           <p:cNvPr id="9" name="footer">
             <a:extLst xmlns:a="http://schemas.openxmlformats.org/drawingml/2006/main">
               <a:ext uri="{FF2B5EF4-FFF2-40B4-BE49-F238E27FC236}">
-                <a16:creationId xmlns:a16="http://schemas.microsoft.com/office/drawing/2014/main" id="{763EC7A2-5F5B-4396-A07B-4431ACBAA367}"/>
+                <a16:creationId xmlns:a16="http://schemas.microsoft.com/office/drawing/2014/main" id="{FC336ACF-4A93-40B8-B842-64FA15EF69A0}"/>
               </a:ext>
             </a:extLst>
           </p:cNvPr>
@@ -12514,7 +12514,7 @@
           <p:cNvPr id="10" name="slide-number">
             <a:extLst xmlns:a="http://schemas.openxmlformats.org/drawingml/2006/main">
               <a:ext uri="{FF2B5EF4-FFF2-40B4-BE49-F238E27FC236}">
-                <a16:creationId xmlns:a16="http://schemas.microsoft.com/office/drawing/2014/main" id="{5065DC05-1A16-48D7-8421-32039EABC66A}"/>
+                <a16:creationId xmlns:a16="http://schemas.microsoft.com/office/drawing/2014/main" id="{7B4B5A1A-C41B-48AE-B909-FD4BCFBEB754}"/>
               </a:ext>
             </a:extLst>
           </p:cNvPr>
@@ -12580,7 +12580,7 @@
     </p:spTree>
     <p:extLst>
       <p:ext uri="{BB962C8B-B14F-4D97-AF65-F5344CB8AC3E}">
-        <p14:creationId xmlns:p14="http://schemas.microsoft.com/office/powerpoint/2010/main" val="1468500184"/>
+        <p14:creationId xmlns:p14="http://schemas.microsoft.com/office/powerpoint/2010/main" val="1034431128"/>
       </p:ext>
     </p:extLst>
   </p:cSld>
@@ -12685,7 +12685,7 @@
           <p:cNvPr id="5" name="Image 0">
             <a:extLst xmlns:a="http://schemas.openxmlformats.org/drawingml/2006/main">
               <a:ext uri="{FF2B5EF4-FFF2-40B4-BE49-F238E27FC236}">
-                <a16:creationId xmlns:a16="http://schemas.microsoft.com/office/drawing/2014/main" id="{AE60A9D3-F020-41EB-BD06-90CD6DFD537E}"/>
+                <a16:creationId xmlns:a16="http://schemas.microsoft.com/office/drawing/2014/main" id="{A0D6D5EF-BBA0-4A44-99FD-4520B1F332B8}"/>
               </a:ext>
             </a:extLst>
           </p:cNvPr>
@@ -12695,7 +12695,7 @@
           <p:nvPr/>
         </p:nvPicPr>
         <p:blipFill>
-          <a:blip xmlns:r="http://schemas.openxmlformats.org/officeDocument/2006/relationships" xmlns:a="http://schemas.openxmlformats.org/drawingml/2006/main" r:embed="Rcef71289d1974bf9"/>
+          <a:blip xmlns:r="http://schemas.openxmlformats.org/officeDocument/2006/relationships" xmlns:a="http://schemas.openxmlformats.org/drawingml/2006/main" r:embed="Ra01a1c3a6c7141c2"/>
           <a:stretch xmlns:a="http://schemas.openxmlformats.org/drawingml/2006/main">
             <a:fillRect l="0" t="0" r="0" b="0"/>
           </a:stretch>
@@ -12842,7 +12842,7 @@
           <p:cNvPr id="9" name="Image 1">
             <a:extLst xmlns:a="http://schemas.openxmlformats.org/drawingml/2006/main">
               <a:ext uri="{FF2B5EF4-FFF2-40B4-BE49-F238E27FC236}">
-                <a16:creationId xmlns:a16="http://schemas.microsoft.com/office/drawing/2014/main" id="{5ADEB67A-AAB7-402F-A6BA-FBA32EF36A64}"/>
+                <a16:creationId xmlns:a16="http://schemas.microsoft.com/office/drawing/2014/main" id="{173DBD80-901F-42FA-ACB2-CF9244070598}"/>
               </a:ext>
             </a:extLst>
           </p:cNvPr>
@@ -12852,7 +12852,7 @@
           <p:nvPr/>
         </p:nvPicPr>
         <p:blipFill>
-          <a:blip xmlns:r="http://schemas.openxmlformats.org/officeDocument/2006/relationships" xmlns:a="http://schemas.openxmlformats.org/drawingml/2006/main" r:embed="Rf8728c32664041f0"/>
+          <a:blip xmlns:r="http://schemas.openxmlformats.org/officeDocument/2006/relationships" xmlns:a="http://schemas.openxmlformats.org/drawingml/2006/main" r:embed="Rd21b78cd46684684"/>
           <a:stretch xmlns:a="http://schemas.openxmlformats.org/drawingml/2006/main">
             <a:fillRect l="0" t="0" r="0" b="0"/>
           </a:stretch>
@@ -12999,7 +12999,7 @@
           <p:cNvPr id="13" name="Image 2">
             <a:extLst xmlns:a="http://schemas.openxmlformats.org/drawingml/2006/main">
               <a:ext uri="{FF2B5EF4-FFF2-40B4-BE49-F238E27FC236}">
-                <a16:creationId xmlns:a16="http://schemas.microsoft.com/office/drawing/2014/main" id="{42913FD3-B24B-40F5-BECA-B5775E120933}"/>
+                <a16:creationId xmlns:a16="http://schemas.microsoft.com/office/drawing/2014/main" id="{A404CC57-CC2D-41E9-A683-D491FC04EC7F}"/>
               </a:ext>
             </a:extLst>
           </p:cNvPr>
@@ -13009,7 +13009,7 @@
           <p:nvPr/>
         </p:nvPicPr>
         <p:blipFill>
-          <a:blip xmlns:r="http://schemas.openxmlformats.org/officeDocument/2006/relationships" xmlns:a="http://schemas.openxmlformats.org/drawingml/2006/main" r:embed="Rfd4baa9dee4f4df3"/>
+          <a:blip xmlns:r="http://schemas.openxmlformats.org/officeDocument/2006/relationships" xmlns:a="http://schemas.openxmlformats.org/drawingml/2006/main" r:embed="Re37424e4d3b74525"/>
           <a:stretch xmlns:a="http://schemas.openxmlformats.org/drawingml/2006/main">
             <a:fillRect l="0" t="0" r="0" b="0"/>
           </a:stretch>
@@ -13156,7 +13156,7 @@
           <p:cNvPr id="17" name="Image 3">
             <a:extLst xmlns:a="http://schemas.openxmlformats.org/drawingml/2006/main">
               <a:ext uri="{FF2B5EF4-FFF2-40B4-BE49-F238E27FC236}">
-                <a16:creationId xmlns:a16="http://schemas.microsoft.com/office/drawing/2014/main" id="{42915D88-9E76-40DD-9707-3A620CB2048D}"/>
+                <a16:creationId xmlns:a16="http://schemas.microsoft.com/office/drawing/2014/main" id="{C3DED7CA-8B25-4AB5-B02D-8E76ED1E1064}"/>
               </a:ext>
             </a:extLst>
           </p:cNvPr>
@@ -13166,7 +13166,7 @@
           <p:nvPr/>
         </p:nvPicPr>
         <p:blipFill>
-          <a:blip xmlns:r="http://schemas.openxmlformats.org/officeDocument/2006/relationships" xmlns:a="http://schemas.openxmlformats.org/drawingml/2006/main" r:embed="Rce4ebf78c1574952"/>
+          <a:blip xmlns:r="http://schemas.openxmlformats.org/officeDocument/2006/relationships" xmlns:a="http://schemas.openxmlformats.org/drawingml/2006/main" r:embed="Rcb98634d68864c86"/>
           <a:stretch xmlns:a="http://schemas.openxmlformats.org/drawingml/2006/main">
             <a:fillRect l="0" t="0" r="0" b="0"/>
           </a:stretch>
@@ -14167,7 +14167,7 @@
           <p:cNvPr id="24" name="Image 0">
             <a:extLst xmlns:a="http://schemas.openxmlformats.org/drawingml/2006/main">
               <a:ext uri="{FF2B5EF4-FFF2-40B4-BE49-F238E27FC236}">
-                <a16:creationId xmlns:a16="http://schemas.microsoft.com/office/drawing/2014/main" id="{7AAEA597-2588-41C9-BA83-C1016566BFFD}"/>
+                <a16:creationId xmlns:a16="http://schemas.microsoft.com/office/drawing/2014/main" id="{870ECE73-FF66-494E-9501-218AC9BEFD5C}"/>
               </a:ext>
             </a:extLst>
           </p:cNvPr>
@@ -14177,7 +14177,7 @@
           <p:nvPr/>
         </p:nvPicPr>
         <p:blipFill>
-          <a:blip xmlns:r="http://schemas.openxmlformats.org/officeDocument/2006/relationships" xmlns:a="http://schemas.openxmlformats.org/drawingml/2006/main" r:embed="R72c941954b814385"/>
+          <a:blip xmlns:r="http://schemas.openxmlformats.org/officeDocument/2006/relationships" xmlns:a="http://schemas.openxmlformats.org/drawingml/2006/main" r:embed="R8d56302afeb8404d"/>
           <a:stretch xmlns:a="http://schemas.openxmlformats.org/drawingml/2006/main">
             <a:fillRect l="0" t="0" r="0" b="0"/>
           </a:stretch>
@@ -14692,7 +14692,7 @@
           <p:cNvPr id="11" name="lesson-title">
             <a:extLst xmlns:a="http://schemas.openxmlformats.org/drawingml/2006/main">
               <a:ext uri="{FF2B5EF4-FFF2-40B4-BE49-F238E27FC236}">
-                <a16:creationId xmlns:a16="http://schemas.microsoft.com/office/drawing/2014/main" id="{7FBC3CEC-B66F-46C0-BFA0-69A55C2AD647}"/>
+                <a16:creationId xmlns:a16="http://schemas.microsoft.com/office/drawing/2014/main" id="{BD7ACD31-DFC4-4DEC-A129-C41FD527163B}"/>
               </a:ext>
             </a:extLst>
           </p:cNvPr>
@@ -14760,7 +14760,7 @@
           <p:cNvPr id="2" name="row-label-0">
             <a:extLst xmlns:a="http://schemas.openxmlformats.org/drawingml/2006/main">
               <a:ext uri="{FF2B5EF4-FFF2-40B4-BE49-F238E27FC236}">
-                <a16:creationId xmlns:a16="http://schemas.microsoft.com/office/drawing/2014/main" id="{B6F5B4FF-4571-4E14-9F4C-258B2B7D15AC}"/>
+                <a16:creationId xmlns:a16="http://schemas.microsoft.com/office/drawing/2014/main" id="{DF08DDD0-B92E-40E5-BF3C-D9CACDF98470}"/>
               </a:ext>
             </a:extLst>
           </p:cNvPr>
@@ -14828,7 +14828,7 @@
           <p:cNvPr id="3" name="row-body-0">
             <a:extLst xmlns:a="http://schemas.openxmlformats.org/drawingml/2006/main">
               <a:ext uri="{FF2B5EF4-FFF2-40B4-BE49-F238E27FC236}">
-                <a16:creationId xmlns:a16="http://schemas.microsoft.com/office/drawing/2014/main" id="{69EB316E-E72D-451D-857F-DD16B93E4816}"/>
+                <a16:creationId xmlns:a16="http://schemas.microsoft.com/office/drawing/2014/main" id="{F6F62EBB-80EC-45D3-B5FB-5301D9E9FDD9}"/>
               </a:ext>
             </a:extLst>
           </p:cNvPr>
@@ -14896,7 +14896,7 @@
           <p:cNvPr id="4" name="row-label-1">
             <a:extLst xmlns:a="http://schemas.openxmlformats.org/drawingml/2006/main">
               <a:ext uri="{FF2B5EF4-FFF2-40B4-BE49-F238E27FC236}">
-                <a16:creationId xmlns:a16="http://schemas.microsoft.com/office/drawing/2014/main" id="{D2C0C557-A3AD-4E01-94C4-4F4D0019E212}"/>
+                <a16:creationId xmlns:a16="http://schemas.microsoft.com/office/drawing/2014/main" id="{B63165D7-E046-42F8-AAFB-11C1FC226B10}"/>
               </a:ext>
             </a:extLst>
           </p:cNvPr>
@@ -14964,7 +14964,7 @@
           <p:cNvPr id="5" name="row-body-1">
             <a:extLst xmlns:a="http://schemas.openxmlformats.org/drawingml/2006/main">
               <a:ext uri="{FF2B5EF4-FFF2-40B4-BE49-F238E27FC236}">
-                <a16:creationId xmlns:a16="http://schemas.microsoft.com/office/drawing/2014/main" id="{004C2357-AAC6-4212-A09B-C94FD87B4BBB}"/>
+                <a16:creationId xmlns:a16="http://schemas.microsoft.com/office/drawing/2014/main" id="{62D49F66-2A95-4C8B-B5EE-826E511D60D2}"/>
               </a:ext>
             </a:extLst>
           </p:cNvPr>
@@ -15032,7 +15032,7 @@
           <p:cNvPr id="6" name="row-label-2">
             <a:extLst xmlns:a="http://schemas.openxmlformats.org/drawingml/2006/main">
               <a:ext uri="{FF2B5EF4-FFF2-40B4-BE49-F238E27FC236}">
-                <a16:creationId xmlns:a16="http://schemas.microsoft.com/office/drawing/2014/main" id="{094FDF93-1EBC-49B7-BDBA-B2E680777891}"/>
+                <a16:creationId xmlns:a16="http://schemas.microsoft.com/office/drawing/2014/main" id="{7019C03C-EC0A-4FD1-A4BB-8FD0ADBC6597}"/>
               </a:ext>
             </a:extLst>
           </p:cNvPr>
@@ -15100,7 +15100,7 @@
           <p:cNvPr id="7" name="row-body-2">
             <a:extLst xmlns:a="http://schemas.openxmlformats.org/drawingml/2006/main">
               <a:ext uri="{FF2B5EF4-FFF2-40B4-BE49-F238E27FC236}">
-                <a16:creationId xmlns:a16="http://schemas.microsoft.com/office/drawing/2014/main" id="{1639362B-BC8D-4318-A88D-16E7628A7B7C}"/>
+                <a16:creationId xmlns:a16="http://schemas.microsoft.com/office/drawing/2014/main" id="{8CB48831-7A7B-4AF6-9357-605FBEEF5759}"/>
               </a:ext>
             </a:extLst>
           </p:cNvPr>
@@ -15168,7 +15168,7 @@
           <p:cNvPr id="8" name="takeaway">
             <a:extLst xmlns:a="http://schemas.openxmlformats.org/drawingml/2006/main">
               <a:ext uri="{FF2B5EF4-FFF2-40B4-BE49-F238E27FC236}">
-                <a16:creationId xmlns:a16="http://schemas.microsoft.com/office/drawing/2014/main" id="{CEA6AE8B-93D6-4CF0-B477-4213C4158483}"/>
+                <a16:creationId xmlns:a16="http://schemas.microsoft.com/office/drawing/2014/main" id="{AD062456-7945-401E-8DF9-E434B4455AD2}"/>
               </a:ext>
             </a:extLst>
           </p:cNvPr>
@@ -15236,7 +15236,7 @@
           <p:cNvPr id="9" name="footer">
             <a:extLst xmlns:a="http://schemas.openxmlformats.org/drawingml/2006/main">
               <a:ext uri="{FF2B5EF4-FFF2-40B4-BE49-F238E27FC236}">
-                <a16:creationId xmlns:a16="http://schemas.microsoft.com/office/drawing/2014/main" id="{9026984D-0C84-4FCC-80BE-D3126115836D}"/>
+                <a16:creationId xmlns:a16="http://schemas.microsoft.com/office/drawing/2014/main" id="{682045FD-FBD3-479D-B231-E018AD33BFC9}"/>
               </a:ext>
             </a:extLst>
           </p:cNvPr>
@@ -15304,7 +15304,7 @@
           <p:cNvPr id="10" name="slide-number">
             <a:extLst xmlns:a="http://schemas.openxmlformats.org/drawingml/2006/main">
               <a:ext uri="{FF2B5EF4-FFF2-40B4-BE49-F238E27FC236}">
-                <a16:creationId xmlns:a16="http://schemas.microsoft.com/office/drawing/2014/main" id="{7DE6B972-DEDA-4107-B67D-FAEBEF5EBDE5}"/>
+                <a16:creationId xmlns:a16="http://schemas.microsoft.com/office/drawing/2014/main" id="{1C273CC3-7595-41D8-BC3A-BCA76BEB16B4}"/>
               </a:ext>
             </a:extLst>
           </p:cNvPr>
@@ -15370,7 +15370,7 @@
     </p:spTree>
     <p:extLst>
       <p:ext uri="{BB962C8B-B14F-4D97-AF65-F5344CB8AC3E}">
-        <p14:creationId xmlns:p14="http://schemas.microsoft.com/office/powerpoint/2010/main" val="1655728477"/>
+        <p14:creationId xmlns:p14="http://schemas.microsoft.com/office/powerpoint/2010/main" val="193992988"/>
       </p:ext>
     </p:extLst>
   </p:cSld>
@@ -15475,7 +15475,7 @@
           <p:cNvPr id="5" name="Image 0">
             <a:extLst xmlns:a="http://schemas.openxmlformats.org/drawingml/2006/main">
               <a:ext uri="{FF2B5EF4-FFF2-40B4-BE49-F238E27FC236}">
-                <a16:creationId xmlns:a16="http://schemas.microsoft.com/office/drawing/2014/main" id="{65EA48CB-7207-4FA0-9DFF-E8676E75B6BE}"/>
+                <a16:creationId xmlns:a16="http://schemas.microsoft.com/office/drawing/2014/main" id="{60F0A44A-1C83-4471-920E-913FAB74FCF0}"/>
               </a:ext>
             </a:extLst>
           </p:cNvPr>
@@ -15485,7 +15485,7 @@
           <p:nvPr/>
         </p:nvPicPr>
         <p:blipFill>
-          <a:blip xmlns:r="http://schemas.openxmlformats.org/officeDocument/2006/relationships" xmlns:a="http://schemas.openxmlformats.org/drawingml/2006/main" r:embed="R7367fdcd7a924cb4"/>
+          <a:blip xmlns:r="http://schemas.openxmlformats.org/officeDocument/2006/relationships" xmlns:a="http://schemas.openxmlformats.org/drawingml/2006/main" r:embed="R51b8371d0f084703"/>
           <a:stretch xmlns:a="http://schemas.openxmlformats.org/drawingml/2006/main">
             <a:fillRect l="0" t="0" r="0" b="0"/>
           </a:stretch>
@@ -15632,7 +15632,7 @@
           <p:cNvPr id="9" name="Image 1">
             <a:extLst xmlns:a="http://schemas.openxmlformats.org/drawingml/2006/main">
               <a:ext uri="{FF2B5EF4-FFF2-40B4-BE49-F238E27FC236}">
-                <a16:creationId xmlns:a16="http://schemas.microsoft.com/office/drawing/2014/main" id="{F7658398-22C1-4095-B748-4F90C24CC012}"/>
+                <a16:creationId xmlns:a16="http://schemas.microsoft.com/office/drawing/2014/main" id="{AA735DF9-8C40-4F1D-9B58-75FF14496981}"/>
               </a:ext>
             </a:extLst>
           </p:cNvPr>
@@ -15642,7 +15642,7 @@
           <p:nvPr/>
         </p:nvPicPr>
         <p:blipFill>
-          <a:blip xmlns:r="http://schemas.openxmlformats.org/officeDocument/2006/relationships" xmlns:a="http://schemas.openxmlformats.org/drawingml/2006/main" r:embed="Rd2e5be8df06f4120"/>
+          <a:blip xmlns:r="http://schemas.openxmlformats.org/officeDocument/2006/relationships" xmlns:a="http://schemas.openxmlformats.org/drawingml/2006/main" r:embed="R8fea8587b7154089"/>
           <a:stretch xmlns:a="http://schemas.openxmlformats.org/drawingml/2006/main">
             <a:fillRect l="0" t="0" r="0" b="0"/>
           </a:stretch>
@@ -15789,7 +15789,7 @@
           <p:cNvPr id="13" name="Image 2">
             <a:extLst xmlns:a="http://schemas.openxmlformats.org/drawingml/2006/main">
               <a:ext uri="{FF2B5EF4-FFF2-40B4-BE49-F238E27FC236}">
-                <a16:creationId xmlns:a16="http://schemas.microsoft.com/office/drawing/2014/main" id="{2741966C-5A33-41A9-9EF3-29F765C917C7}"/>
+                <a16:creationId xmlns:a16="http://schemas.microsoft.com/office/drawing/2014/main" id="{E0347E01-411D-48E0-A1FA-AE4D7DF72F8D}"/>
               </a:ext>
             </a:extLst>
           </p:cNvPr>
@@ -15799,7 +15799,7 @@
           <p:nvPr/>
         </p:nvPicPr>
         <p:blipFill>
-          <a:blip xmlns:r="http://schemas.openxmlformats.org/officeDocument/2006/relationships" xmlns:a="http://schemas.openxmlformats.org/drawingml/2006/main" r:embed="R08b9b9f4ffe348d9"/>
+          <a:blip xmlns:r="http://schemas.openxmlformats.org/officeDocument/2006/relationships" xmlns:a="http://schemas.openxmlformats.org/drawingml/2006/main" r:embed="R4f21876d31844d34"/>
           <a:stretch xmlns:a="http://schemas.openxmlformats.org/drawingml/2006/main">
             <a:fillRect l="0" t="0" r="0" b="0"/>
           </a:stretch>
@@ -16038,7 +16038,7 @@
           <p:cNvPr id="11" name="lesson-title">
             <a:extLst xmlns:a="http://schemas.openxmlformats.org/drawingml/2006/main">
               <a:ext uri="{FF2B5EF4-FFF2-40B4-BE49-F238E27FC236}">
-                <a16:creationId xmlns:a16="http://schemas.microsoft.com/office/drawing/2014/main" id="{0F981ED8-3040-4C1D-A007-1E373655E659}"/>
+                <a16:creationId xmlns:a16="http://schemas.microsoft.com/office/drawing/2014/main" id="{0FD76956-5DA8-425E-AD01-114EDFEE1699}"/>
               </a:ext>
             </a:extLst>
           </p:cNvPr>
@@ -16106,7 +16106,7 @@
           <p:cNvPr id="2" name="row-label-0">
             <a:extLst xmlns:a="http://schemas.openxmlformats.org/drawingml/2006/main">
               <a:ext uri="{FF2B5EF4-FFF2-40B4-BE49-F238E27FC236}">
-                <a16:creationId xmlns:a16="http://schemas.microsoft.com/office/drawing/2014/main" id="{3338677C-1FE4-4191-8A24-DE49C5882733}"/>
+                <a16:creationId xmlns:a16="http://schemas.microsoft.com/office/drawing/2014/main" id="{3053F198-796D-4214-9155-F014F9600A58}"/>
               </a:ext>
             </a:extLst>
           </p:cNvPr>
@@ -16174,7 +16174,7 @@
           <p:cNvPr id="3" name="row-body-0">
             <a:extLst xmlns:a="http://schemas.openxmlformats.org/drawingml/2006/main">
               <a:ext uri="{FF2B5EF4-FFF2-40B4-BE49-F238E27FC236}">
-                <a16:creationId xmlns:a16="http://schemas.microsoft.com/office/drawing/2014/main" id="{CDEF16B2-E5FE-4F43-A43D-980BB86D1077}"/>
+                <a16:creationId xmlns:a16="http://schemas.microsoft.com/office/drawing/2014/main" id="{8331445E-C6D9-4175-A9BA-03A6DF0CFA88}"/>
               </a:ext>
             </a:extLst>
           </p:cNvPr>
@@ -16242,7 +16242,7 @@
           <p:cNvPr id="4" name="row-label-1">
             <a:extLst xmlns:a="http://schemas.openxmlformats.org/drawingml/2006/main">
               <a:ext uri="{FF2B5EF4-FFF2-40B4-BE49-F238E27FC236}">
-                <a16:creationId xmlns:a16="http://schemas.microsoft.com/office/drawing/2014/main" id="{4CE55ECA-4783-4CBB-BBAE-9755A2B777CE}"/>
+                <a16:creationId xmlns:a16="http://schemas.microsoft.com/office/drawing/2014/main" id="{28E695C3-C677-4AE2-AA70-9B44542103DC}"/>
               </a:ext>
             </a:extLst>
           </p:cNvPr>
@@ -16310,7 +16310,7 @@
           <p:cNvPr id="5" name="row-body-1">
             <a:extLst xmlns:a="http://schemas.openxmlformats.org/drawingml/2006/main">
               <a:ext uri="{FF2B5EF4-FFF2-40B4-BE49-F238E27FC236}">
-                <a16:creationId xmlns:a16="http://schemas.microsoft.com/office/drawing/2014/main" id="{E211C8C0-6182-435D-973C-42E709A6AE63}"/>
+                <a16:creationId xmlns:a16="http://schemas.microsoft.com/office/drawing/2014/main" id="{191690A7-CAAA-443C-A126-272C0FD31737}"/>
               </a:ext>
             </a:extLst>
           </p:cNvPr>
@@ -16378,7 +16378,7 @@
           <p:cNvPr id="6" name="row-label-2">
             <a:extLst xmlns:a="http://schemas.openxmlformats.org/drawingml/2006/main">
               <a:ext uri="{FF2B5EF4-FFF2-40B4-BE49-F238E27FC236}">
-                <a16:creationId xmlns:a16="http://schemas.microsoft.com/office/drawing/2014/main" id="{1E314A37-91AA-4443-BD79-2DE0B34DF8FC}"/>
+                <a16:creationId xmlns:a16="http://schemas.microsoft.com/office/drawing/2014/main" id="{D95B7382-7256-47E6-8246-329FCCEF3449}"/>
               </a:ext>
             </a:extLst>
           </p:cNvPr>
@@ -16446,7 +16446,7 @@
           <p:cNvPr id="7" name="row-body-2">
             <a:extLst xmlns:a="http://schemas.openxmlformats.org/drawingml/2006/main">
               <a:ext uri="{FF2B5EF4-FFF2-40B4-BE49-F238E27FC236}">
-                <a16:creationId xmlns:a16="http://schemas.microsoft.com/office/drawing/2014/main" id="{A4D45C3C-4E95-4BA8-8F8C-9C56FD6DF595}"/>
+                <a16:creationId xmlns:a16="http://schemas.microsoft.com/office/drawing/2014/main" id="{39A04B6E-1D50-44E4-B475-78CA4590907B}"/>
               </a:ext>
             </a:extLst>
           </p:cNvPr>
@@ -16514,7 +16514,7 @@
           <p:cNvPr id="8" name="takeaway">
             <a:extLst xmlns:a="http://schemas.openxmlformats.org/drawingml/2006/main">
               <a:ext uri="{FF2B5EF4-FFF2-40B4-BE49-F238E27FC236}">
-                <a16:creationId xmlns:a16="http://schemas.microsoft.com/office/drawing/2014/main" id="{8E06B198-54EF-49D0-AA39-0F4B0E7BB897}"/>
+                <a16:creationId xmlns:a16="http://schemas.microsoft.com/office/drawing/2014/main" id="{3FC2B730-BBE3-4C4C-9EBC-B69F719AB10E}"/>
               </a:ext>
             </a:extLst>
           </p:cNvPr>
@@ -16582,7 +16582,7 @@
           <p:cNvPr id="9" name="footer">
             <a:extLst xmlns:a="http://schemas.openxmlformats.org/drawingml/2006/main">
               <a:ext uri="{FF2B5EF4-FFF2-40B4-BE49-F238E27FC236}">
-                <a16:creationId xmlns:a16="http://schemas.microsoft.com/office/drawing/2014/main" id="{2DB9399E-D76B-4CDD-889E-9055AFBCE95C}"/>
+                <a16:creationId xmlns:a16="http://schemas.microsoft.com/office/drawing/2014/main" id="{576B8016-8727-41CB-9534-5A9C64ECF27D}"/>
               </a:ext>
             </a:extLst>
           </p:cNvPr>
@@ -16650,7 +16650,7 @@
           <p:cNvPr id="10" name="slide-number">
             <a:extLst xmlns:a="http://schemas.openxmlformats.org/drawingml/2006/main">
               <a:ext uri="{FF2B5EF4-FFF2-40B4-BE49-F238E27FC236}">
-                <a16:creationId xmlns:a16="http://schemas.microsoft.com/office/drawing/2014/main" id="{462B9C5E-22BB-4928-A6C4-7E8A7CFABCF0}"/>
+                <a16:creationId xmlns:a16="http://schemas.microsoft.com/office/drawing/2014/main" id="{12D01F29-F33B-4252-B8B7-BDD515551065}"/>
               </a:ext>
             </a:extLst>
           </p:cNvPr>
@@ -16716,7 +16716,7 @@
     </p:spTree>
     <p:extLst>
       <p:ext uri="{BB962C8B-B14F-4D97-AF65-F5344CB8AC3E}">
-        <p14:creationId xmlns:p14="http://schemas.microsoft.com/office/powerpoint/2010/main" val="2013931929"/>
+        <p14:creationId xmlns:p14="http://schemas.microsoft.com/office/powerpoint/2010/main" val="349632069"/>
       </p:ext>
     </p:extLst>
   </p:cSld>
@@ -16821,7 +16821,7 @@
           <p:cNvPr id="5" name="Image 0">
             <a:extLst xmlns:a="http://schemas.openxmlformats.org/drawingml/2006/main">
               <a:ext uri="{FF2B5EF4-FFF2-40B4-BE49-F238E27FC236}">
-                <a16:creationId xmlns:a16="http://schemas.microsoft.com/office/drawing/2014/main" id="{BC1A7F5A-859A-4E9C-8CBD-ED78B31F300D}"/>
+                <a16:creationId xmlns:a16="http://schemas.microsoft.com/office/drawing/2014/main" id="{DA9DC6B0-BBB2-4537-948C-D505BA8A56B6}"/>
               </a:ext>
             </a:extLst>
           </p:cNvPr>
@@ -16831,7 +16831,7 @@
           <p:nvPr/>
         </p:nvPicPr>
         <p:blipFill>
-          <a:blip xmlns:r="http://schemas.openxmlformats.org/officeDocument/2006/relationships" xmlns:a="http://schemas.openxmlformats.org/drawingml/2006/main" r:embed="Rd3cb9a5d62e8490d"/>
+          <a:blip xmlns:r="http://schemas.openxmlformats.org/officeDocument/2006/relationships" xmlns:a="http://schemas.openxmlformats.org/drawingml/2006/main" r:embed="Rcfe37822134f437d"/>
           <a:stretch xmlns:a="http://schemas.openxmlformats.org/drawingml/2006/main">
             <a:fillRect l="0" t="0" r="0" b="0"/>
           </a:stretch>
@@ -17701,7 +17701,7 @@
           <p:cNvPr id="11" name="lesson-title">
             <a:extLst xmlns:a="http://schemas.openxmlformats.org/drawingml/2006/main">
               <a:ext uri="{FF2B5EF4-FFF2-40B4-BE49-F238E27FC236}">
-                <a16:creationId xmlns:a16="http://schemas.microsoft.com/office/drawing/2014/main" id="{E27644C2-E32A-4028-A626-794C480E565E}"/>
+                <a16:creationId xmlns:a16="http://schemas.microsoft.com/office/drawing/2014/main" id="{1D4318B6-D5C3-4F00-9BFB-7866A99FAF2E}"/>
               </a:ext>
             </a:extLst>
           </p:cNvPr>
@@ -17759,7 +17759,7 @@
                 <a:ea typeface="Bookman Old Style"/>
                 <a:cs typeface="Bookman Old Style"/>
               </a:rPr>
-              <a:t>Show what you learned</a:t>
+              <a:t>Checkpoint 4: explain your result</a:t>
             </a:r>
           </a:p>
         </p:txBody>
@@ -17769,7 +17769,7 @@
           <p:cNvPr id="2" name="row-label-0">
             <a:extLst xmlns:a="http://schemas.openxmlformats.org/drawingml/2006/main">
               <a:ext uri="{FF2B5EF4-FFF2-40B4-BE49-F238E27FC236}">
-                <a16:creationId xmlns:a16="http://schemas.microsoft.com/office/drawing/2014/main" id="{5418BA07-7A93-443C-8AA9-036F7A6E48BC}"/>
+                <a16:creationId xmlns:a16="http://schemas.microsoft.com/office/drawing/2014/main" id="{E95A0940-624B-4114-B3AE-6FDD1048101B}"/>
               </a:ext>
             </a:extLst>
           </p:cNvPr>
@@ -17837,7 +17837,7 @@
           <p:cNvPr id="3" name="row-body-0">
             <a:extLst xmlns:a="http://schemas.openxmlformats.org/drawingml/2006/main">
               <a:ext uri="{FF2B5EF4-FFF2-40B4-BE49-F238E27FC236}">
-                <a16:creationId xmlns:a16="http://schemas.microsoft.com/office/drawing/2014/main" id="{0A71D523-5342-440B-B903-E3E6857613AD}"/>
+                <a16:creationId xmlns:a16="http://schemas.microsoft.com/office/drawing/2014/main" id="{CF4B7172-C4E4-45D4-AB33-3676B7386D02}"/>
               </a:ext>
             </a:extLst>
           </p:cNvPr>
@@ -17905,7 +17905,7 @@
           <p:cNvPr id="4" name="row-label-1">
             <a:extLst xmlns:a="http://schemas.openxmlformats.org/drawingml/2006/main">
               <a:ext uri="{FF2B5EF4-FFF2-40B4-BE49-F238E27FC236}">
-                <a16:creationId xmlns:a16="http://schemas.microsoft.com/office/drawing/2014/main" id="{DC186E89-192C-4FCA-9B8F-31396DCE9507}"/>
+                <a16:creationId xmlns:a16="http://schemas.microsoft.com/office/drawing/2014/main" id="{2C0924DA-E20A-4BA1-94D4-90DAAD9BA20C}"/>
               </a:ext>
             </a:extLst>
           </p:cNvPr>
@@ -17973,7 +17973,7 @@
           <p:cNvPr id="5" name="row-body-1">
             <a:extLst xmlns:a="http://schemas.openxmlformats.org/drawingml/2006/main">
               <a:ext uri="{FF2B5EF4-FFF2-40B4-BE49-F238E27FC236}">
-                <a16:creationId xmlns:a16="http://schemas.microsoft.com/office/drawing/2014/main" id="{B68565F8-8D24-400F-A6D5-09F7C61D97A8}"/>
+                <a16:creationId xmlns:a16="http://schemas.microsoft.com/office/drawing/2014/main" id="{E1E8F669-D712-4296-8DBA-6FF714A09C98}"/>
               </a:ext>
             </a:extLst>
           </p:cNvPr>
@@ -18041,7 +18041,7 @@
           <p:cNvPr id="6" name="row-label-2">
             <a:extLst xmlns:a="http://schemas.openxmlformats.org/drawingml/2006/main">
               <a:ext uri="{FF2B5EF4-FFF2-40B4-BE49-F238E27FC236}">
-                <a16:creationId xmlns:a16="http://schemas.microsoft.com/office/drawing/2014/main" id="{CD0618D6-242F-4B50-B173-AD0FE7B6C568}"/>
+                <a16:creationId xmlns:a16="http://schemas.microsoft.com/office/drawing/2014/main" id="{207A5481-CD85-4C04-AF88-1471B61702FC}"/>
               </a:ext>
             </a:extLst>
           </p:cNvPr>
@@ -18109,7 +18109,7 @@
           <p:cNvPr id="7" name="row-body-2">
             <a:extLst xmlns:a="http://schemas.openxmlformats.org/drawingml/2006/main">
               <a:ext uri="{FF2B5EF4-FFF2-40B4-BE49-F238E27FC236}">
-                <a16:creationId xmlns:a16="http://schemas.microsoft.com/office/drawing/2014/main" id="{DF790025-1A02-46F1-9171-99E598CE3C24}"/>
+                <a16:creationId xmlns:a16="http://schemas.microsoft.com/office/drawing/2014/main" id="{CE4CC3F6-900F-4F5A-A692-117C57C5651B}"/>
               </a:ext>
             </a:extLst>
           </p:cNvPr>
@@ -18177,7 +18177,7 @@
           <p:cNvPr id="8" name="takeaway">
             <a:extLst xmlns:a="http://schemas.openxmlformats.org/drawingml/2006/main">
               <a:ext uri="{FF2B5EF4-FFF2-40B4-BE49-F238E27FC236}">
-                <a16:creationId xmlns:a16="http://schemas.microsoft.com/office/drawing/2014/main" id="{C441F400-3602-48E6-8BB6-128D784E3086}"/>
+                <a16:creationId xmlns:a16="http://schemas.microsoft.com/office/drawing/2014/main" id="{6F907B37-F853-4705-AF0D-A3A18C61E183}"/>
               </a:ext>
             </a:extLst>
           </p:cNvPr>
@@ -18235,7 +18235,7 @@
                 <a:ea typeface="Calibri"/>
                 <a:cs typeface="Calibri"/>
               </a:rPr>
-              <a:t>You should be able to explain your change without the AI.</a:t>
+              <a:t>Save your own note. Mark predictions as not run.</a:t>
             </a:r>
           </a:p>
         </p:txBody>
@@ -18245,7 +18245,7 @@
           <p:cNvPr id="9" name="footer">
             <a:extLst xmlns:a="http://schemas.openxmlformats.org/drawingml/2006/main">
               <a:ext uri="{FF2B5EF4-FFF2-40B4-BE49-F238E27FC236}">
-                <a16:creationId xmlns:a16="http://schemas.microsoft.com/office/drawing/2014/main" id="{B758D6DE-4EFA-4254-9CF6-DF461BC9B2FB}"/>
+                <a16:creationId xmlns:a16="http://schemas.microsoft.com/office/drawing/2014/main" id="{957A7D0A-F6EB-45D5-B204-C8ADE1CD7EC0}"/>
               </a:ext>
             </a:extLst>
           </p:cNvPr>
@@ -18313,7 +18313,7 @@
           <p:cNvPr id="10" name="slide-number">
             <a:extLst xmlns:a="http://schemas.openxmlformats.org/drawingml/2006/main">
               <a:ext uri="{FF2B5EF4-FFF2-40B4-BE49-F238E27FC236}">
-                <a16:creationId xmlns:a16="http://schemas.microsoft.com/office/drawing/2014/main" id="{087FD87D-F092-4225-9961-EF7FB05B3ADD}"/>
+                <a16:creationId xmlns:a16="http://schemas.microsoft.com/office/drawing/2014/main" id="{DCBE3CAA-D763-44BF-852B-C4C2BC799B6B}"/>
               </a:ext>
             </a:extLst>
           </p:cNvPr>
@@ -18379,7 +18379,7 @@
     </p:spTree>
     <p:extLst>
       <p:ext uri="{BB962C8B-B14F-4D97-AF65-F5344CB8AC3E}">
-        <p14:creationId xmlns:p14="http://schemas.microsoft.com/office/powerpoint/2010/main" val="320806419"/>
+        <p14:creationId xmlns:p14="http://schemas.microsoft.com/office/powerpoint/2010/main" val="521780992"/>
       </p:ext>
     </p:extLst>
   </p:cSld>
@@ -18410,7 +18410,7 @@
           <p:cNvPr id="11" name="lesson-title">
             <a:extLst xmlns:a="http://schemas.openxmlformats.org/drawingml/2006/main">
               <a:ext uri="{FF2B5EF4-FFF2-40B4-BE49-F238E27FC236}">
-                <a16:creationId xmlns:a16="http://schemas.microsoft.com/office/drawing/2014/main" id="{9AF3D6B4-760B-4195-8161-1E194F98A40B}"/>
+                <a16:creationId xmlns:a16="http://schemas.microsoft.com/office/drawing/2014/main" id="{4505AB44-48C2-4A38-93B4-8F7BE1B5AAAE}"/>
               </a:ext>
             </a:extLst>
           </p:cNvPr>
@@ -18478,7 +18478,7 @@
           <p:cNvPr id="2" name="row-label-0">
             <a:extLst xmlns:a="http://schemas.openxmlformats.org/drawingml/2006/main">
               <a:ext uri="{FF2B5EF4-FFF2-40B4-BE49-F238E27FC236}">
-                <a16:creationId xmlns:a16="http://schemas.microsoft.com/office/drawing/2014/main" id="{318CACC0-84CF-4B2D-96D2-F4C94469EBB4}"/>
+                <a16:creationId xmlns:a16="http://schemas.microsoft.com/office/drawing/2014/main" id="{FDB15E8C-D529-49CA-B92F-378330CACE80}"/>
               </a:ext>
             </a:extLst>
           </p:cNvPr>
@@ -18546,7 +18546,7 @@
           <p:cNvPr id="3" name="row-body-0">
             <a:extLst xmlns:a="http://schemas.openxmlformats.org/drawingml/2006/main">
               <a:ext uri="{FF2B5EF4-FFF2-40B4-BE49-F238E27FC236}">
-                <a16:creationId xmlns:a16="http://schemas.microsoft.com/office/drawing/2014/main" id="{EFF0995E-77C0-4FFD-91CE-B3DA1F7B1975}"/>
+                <a16:creationId xmlns:a16="http://schemas.microsoft.com/office/drawing/2014/main" id="{C9331D79-2A18-4443-B6AC-7832419CD525}"/>
               </a:ext>
             </a:extLst>
           </p:cNvPr>
@@ -18614,7 +18614,7 @@
           <p:cNvPr id="4" name="row-label-1">
             <a:extLst xmlns:a="http://schemas.openxmlformats.org/drawingml/2006/main">
               <a:ext uri="{FF2B5EF4-FFF2-40B4-BE49-F238E27FC236}">
-                <a16:creationId xmlns:a16="http://schemas.microsoft.com/office/drawing/2014/main" id="{836EEF7E-6950-46E7-AE94-8B0FC678069E}"/>
+                <a16:creationId xmlns:a16="http://schemas.microsoft.com/office/drawing/2014/main" id="{8BF05180-0E8E-42CF-8AF1-FAADCFA4B71E}"/>
               </a:ext>
             </a:extLst>
           </p:cNvPr>
@@ -18682,7 +18682,7 @@
           <p:cNvPr id="5" name="row-body-1">
             <a:extLst xmlns:a="http://schemas.openxmlformats.org/drawingml/2006/main">
               <a:ext uri="{FF2B5EF4-FFF2-40B4-BE49-F238E27FC236}">
-                <a16:creationId xmlns:a16="http://schemas.microsoft.com/office/drawing/2014/main" id="{CEA8C505-1A0C-4EF7-B618-07BDBD9B9F40}"/>
+                <a16:creationId xmlns:a16="http://schemas.microsoft.com/office/drawing/2014/main" id="{F203F758-FC11-439B-9251-C40632251B9A}"/>
               </a:ext>
             </a:extLst>
           </p:cNvPr>
@@ -18750,7 +18750,7 @@
           <p:cNvPr id="6" name="row-label-2">
             <a:extLst xmlns:a="http://schemas.openxmlformats.org/drawingml/2006/main">
               <a:ext uri="{FF2B5EF4-FFF2-40B4-BE49-F238E27FC236}">
-                <a16:creationId xmlns:a16="http://schemas.microsoft.com/office/drawing/2014/main" id="{3A77AC01-6935-4562-9329-C7E5489009DD}"/>
+                <a16:creationId xmlns:a16="http://schemas.microsoft.com/office/drawing/2014/main" id="{CE1AD0E2-47B3-4B76-B129-05B557C9B1A2}"/>
               </a:ext>
             </a:extLst>
           </p:cNvPr>
@@ -18818,7 +18818,7 @@
           <p:cNvPr id="7" name="row-body-2">
             <a:extLst xmlns:a="http://schemas.openxmlformats.org/drawingml/2006/main">
               <a:ext uri="{FF2B5EF4-FFF2-40B4-BE49-F238E27FC236}">
-                <a16:creationId xmlns:a16="http://schemas.microsoft.com/office/drawing/2014/main" id="{0A81FBDF-5F16-4F74-834F-157392626E2C}"/>
+                <a16:creationId xmlns:a16="http://schemas.microsoft.com/office/drawing/2014/main" id="{3FBEC0EE-3480-4131-B3B7-63453CBF093F}"/>
               </a:ext>
             </a:extLst>
           </p:cNvPr>
@@ -18886,7 +18886,7 @@
           <p:cNvPr id="8" name="takeaway">
             <a:extLst xmlns:a="http://schemas.openxmlformats.org/drawingml/2006/main">
               <a:ext uri="{FF2B5EF4-FFF2-40B4-BE49-F238E27FC236}">
-                <a16:creationId xmlns:a16="http://schemas.microsoft.com/office/drawing/2014/main" id="{FC979CB8-4927-4CC2-AF49-2AB63BB0BB28}"/>
+                <a16:creationId xmlns:a16="http://schemas.microsoft.com/office/drawing/2014/main" id="{F2FD45E3-05B4-4FEF-9231-FE2B0BDF99D7}"/>
               </a:ext>
             </a:extLst>
           </p:cNvPr>
@@ -18954,7 +18954,7 @@
           <p:cNvPr id="9" name="footer">
             <a:extLst xmlns:a="http://schemas.openxmlformats.org/drawingml/2006/main">
               <a:ext uri="{FF2B5EF4-FFF2-40B4-BE49-F238E27FC236}">
-                <a16:creationId xmlns:a16="http://schemas.microsoft.com/office/drawing/2014/main" id="{228E78E4-80B7-4025-8B68-6D47BE726890}"/>
+                <a16:creationId xmlns:a16="http://schemas.microsoft.com/office/drawing/2014/main" id="{AC6703D9-7E10-461F-8ADD-AE74B8B56673}"/>
               </a:ext>
             </a:extLst>
           </p:cNvPr>
@@ -19022,7 +19022,7 @@
           <p:cNvPr id="10" name="slide-number">
             <a:extLst xmlns:a="http://schemas.openxmlformats.org/drawingml/2006/main">
               <a:ext uri="{FF2B5EF4-FFF2-40B4-BE49-F238E27FC236}">
-                <a16:creationId xmlns:a16="http://schemas.microsoft.com/office/drawing/2014/main" id="{0C4DB184-23ED-4246-A56D-B5AF782AAC67}"/>
+                <a16:creationId xmlns:a16="http://schemas.microsoft.com/office/drawing/2014/main" id="{54460228-DB9C-46FA-B01A-5597005F64A3}"/>
               </a:ext>
             </a:extLst>
           </p:cNvPr>
@@ -19088,7 +19088,7 @@
     </p:spTree>
     <p:extLst>
       <p:ext uri="{BB962C8B-B14F-4D97-AF65-F5344CB8AC3E}">
-        <p14:creationId xmlns:p14="http://schemas.microsoft.com/office/powerpoint/2010/main" val="1653186834"/>
+        <p14:creationId xmlns:p14="http://schemas.microsoft.com/office/powerpoint/2010/main" val="430846756"/>
       </p:ext>
     </p:extLst>
   </p:cSld>
@@ -20253,7 +20253,7 @@
           <p:cNvPr id="11" name="lesson-title">
             <a:extLst xmlns:a="http://schemas.openxmlformats.org/drawingml/2006/main">
               <a:ext uri="{FF2B5EF4-FFF2-40B4-BE49-F238E27FC236}">
-                <a16:creationId xmlns:a16="http://schemas.microsoft.com/office/drawing/2014/main" id="{61C869E0-74DB-429C-B5A0-C0668FBBAAF4}"/>
+                <a16:creationId xmlns:a16="http://schemas.microsoft.com/office/drawing/2014/main" id="{C913B5C1-2F5E-4DC5-B53F-17EF83F67A9C}"/>
               </a:ext>
             </a:extLst>
           </p:cNvPr>
@@ -20321,7 +20321,7 @@
           <p:cNvPr id="2" name="row-label-0">
             <a:extLst xmlns:a="http://schemas.openxmlformats.org/drawingml/2006/main">
               <a:ext uri="{FF2B5EF4-FFF2-40B4-BE49-F238E27FC236}">
-                <a16:creationId xmlns:a16="http://schemas.microsoft.com/office/drawing/2014/main" id="{B301E8CC-1D4E-4CAD-9D20-BC7BD270A99C}"/>
+                <a16:creationId xmlns:a16="http://schemas.microsoft.com/office/drawing/2014/main" id="{E592B916-6D0F-45A3-BD57-96F67BD2157C}"/>
               </a:ext>
             </a:extLst>
           </p:cNvPr>
@@ -20389,7 +20389,7 @@
           <p:cNvPr id="3" name="row-body-0">
             <a:extLst xmlns:a="http://schemas.openxmlformats.org/drawingml/2006/main">
               <a:ext uri="{FF2B5EF4-FFF2-40B4-BE49-F238E27FC236}">
-                <a16:creationId xmlns:a16="http://schemas.microsoft.com/office/drawing/2014/main" id="{D76E0614-7085-4805-8A43-123A4DC6B19B}"/>
+                <a16:creationId xmlns:a16="http://schemas.microsoft.com/office/drawing/2014/main" id="{34D4991A-1D48-4531-A7B6-D669C06CB393}"/>
               </a:ext>
             </a:extLst>
           </p:cNvPr>
@@ -20457,7 +20457,7 @@
           <p:cNvPr id="4" name="row-label-1">
             <a:extLst xmlns:a="http://schemas.openxmlformats.org/drawingml/2006/main">
               <a:ext uri="{FF2B5EF4-FFF2-40B4-BE49-F238E27FC236}">
-                <a16:creationId xmlns:a16="http://schemas.microsoft.com/office/drawing/2014/main" id="{ED95F494-65F2-4DBE-94AE-F53715DF3ADE}"/>
+                <a16:creationId xmlns:a16="http://schemas.microsoft.com/office/drawing/2014/main" id="{DC43372F-7D4B-47EF-89A0-83EA223CE9F1}"/>
               </a:ext>
             </a:extLst>
           </p:cNvPr>
@@ -20525,7 +20525,7 @@
           <p:cNvPr id="5" name="row-body-1">
             <a:extLst xmlns:a="http://schemas.openxmlformats.org/drawingml/2006/main">
               <a:ext uri="{FF2B5EF4-FFF2-40B4-BE49-F238E27FC236}">
-                <a16:creationId xmlns:a16="http://schemas.microsoft.com/office/drawing/2014/main" id="{EF5E409E-3E6C-4D31-BCEA-2FA6248A135A}"/>
+                <a16:creationId xmlns:a16="http://schemas.microsoft.com/office/drawing/2014/main" id="{D0D645F4-3DAB-4C3B-B4DC-D4B768FA054E}"/>
               </a:ext>
             </a:extLst>
           </p:cNvPr>
@@ -20593,7 +20593,7 @@
           <p:cNvPr id="6" name="row-label-2">
             <a:extLst xmlns:a="http://schemas.openxmlformats.org/drawingml/2006/main">
               <a:ext uri="{FF2B5EF4-FFF2-40B4-BE49-F238E27FC236}">
-                <a16:creationId xmlns:a16="http://schemas.microsoft.com/office/drawing/2014/main" id="{D1C9E9D9-CDCF-4E65-93DD-FAC95C54DD5D}"/>
+                <a16:creationId xmlns:a16="http://schemas.microsoft.com/office/drawing/2014/main" id="{4CBD1724-3CF7-4832-AF4D-D2E28C7B940F}"/>
               </a:ext>
             </a:extLst>
           </p:cNvPr>
@@ -20661,7 +20661,7 @@
           <p:cNvPr id="7" name="row-body-2">
             <a:extLst xmlns:a="http://schemas.openxmlformats.org/drawingml/2006/main">
               <a:ext uri="{FF2B5EF4-FFF2-40B4-BE49-F238E27FC236}">
-                <a16:creationId xmlns:a16="http://schemas.microsoft.com/office/drawing/2014/main" id="{2819878B-1BDE-45F0-9B18-64E345F1E931}"/>
+                <a16:creationId xmlns:a16="http://schemas.microsoft.com/office/drawing/2014/main" id="{A2003517-8DE1-4C9D-902B-11D973A5D423}"/>
               </a:ext>
             </a:extLst>
           </p:cNvPr>
@@ -20729,7 +20729,7 @@
           <p:cNvPr id="8" name="takeaway">
             <a:extLst xmlns:a="http://schemas.openxmlformats.org/drawingml/2006/main">
               <a:ext uri="{FF2B5EF4-FFF2-40B4-BE49-F238E27FC236}">
-                <a16:creationId xmlns:a16="http://schemas.microsoft.com/office/drawing/2014/main" id="{21719755-2C37-47AF-8A7A-EA7AE1DB4B95}"/>
+                <a16:creationId xmlns:a16="http://schemas.microsoft.com/office/drawing/2014/main" id="{3E22CDC3-E2BF-4665-AD69-32B168CF3994}"/>
               </a:ext>
             </a:extLst>
           </p:cNvPr>
@@ -20787,7 +20787,7 @@
                 <a:ea typeface="Calibri"/>
                 <a:cs typeface="Calibri"/>
               </a:rPr>
-              <a:t>Use the walkthrough even if you are following offline.</a:t>
+              <a:t>Watch the walkthrough. Personal API setup is optional.</a:t>
             </a:r>
           </a:p>
         </p:txBody>
@@ -20797,7 +20797,7 @@
           <p:cNvPr id="9" name="footer">
             <a:extLst xmlns:a="http://schemas.openxmlformats.org/drawingml/2006/main">
               <a:ext uri="{FF2B5EF4-FFF2-40B4-BE49-F238E27FC236}">
-                <a16:creationId xmlns:a16="http://schemas.microsoft.com/office/drawing/2014/main" id="{17F364E8-D91A-4C11-B080-4CA0196DA52B}"/>
+                <a16:creationId xmlns:a16="http://schemas.microsoft.com/office/drawing/2014/main" id="{8E290FB7-5DF6-46F2-8196-1E81B8286361}"/>
               </a:ext>
             </a:extLst>
           </p:cNvPr>
@@ -20865,7 +20865,7 @@
           <p:cNvPr id="10" name="slide-number">
             <a:extLst xmlns:a="http://schemas.openxmlformats.org/drawingml/2006/main">
               <a:ext uri="{FF2B5EF4-FFF2-40B4-BE49-F238E27FC236}">
-                <a16:creationId xmlns:a16="http://schemas.microsoft.com/office/drawing/2014/main" id="{E23D2093-D939-4CEE-A986-EE931B3C311E}"/>
+                <a16:creationId xmlns:a16="http://schemas.microsoft.com/office/drawing/2014/main" id="{ADB0020E-E647-4D48-98C2-41B853FD3536}"/>
               </a:ext>
             </a:extLst>
           </p:cNvPr>
@@ -20931,7 +20931,7 @@
     </p:spTree>
     <p:extLst>
       <p:ext uri="{BB962C8B-B14F-4D97-AF65-F5344CB8AC3E}">
-        <p14:creationId xmlns:p14="http://schemas.microsoft.com/office/powerpoint/2010/main" val="553684671"/>
+        <p14:creationId xmlns:p14="http://schemas.microsoft.com/office/powerpoint/2010/main" val="2131876688"/>
       </p:ext>
     </p:extLst>
   </p:cSld>
@@ -20962,7 +20962,7 @@
           <p:cNvPr id="6" name="lesson-title">
             <a:extLst xmlns:a="http://schemas.openxmlformats.org/drawingml/2006/main">
               <a:ext uri="{FF2B5EF4-FFF2-40B4-BE49-F238E27FC236}">
-                <a16:creationId xmlns:a16="http://schemas.microsoft.com/office/drawing/2014/main" id="{164CFD2C-0AE4-435C-AC4F-037E7F94CCD8}"/>
+                <a16:creationId xmlns:a16="http://schemas.microsoft.com/office/drawing/2014/main" id="{495E312F-0403-412D-8F06-6A08C6094348}"/>
               </a:ext>
             </a:extLst>
           </p:cNvPr>
@@ -21030,7 +21030,7 @@
           <p:cNvPr id="2" name="code-example">
             <a:extLst xmlns:a="http://schemas.openxmlformats.org/drawingml/2006/main">
               <a:ext uri="{FF2B5EF4-FFF2-40B4-BE49-F238E27FC236}">
-                <a16:creationId xmlns:a16="http://schemas.microsoft.com/office/drawing/2014/main" id="{30D21C88-2A43-4D16-AE82-0110DFD44358}"/>
+                <a16:creationId xmlns:a16="http://schemas.microsoft.com/office/drawing/2014/main" id="{D151DC08-1781-470D-98D8-DC4E547AFA4D}"/>
               </a:ext>
             </a:extLst>
           </p:cNvPr>
@@ -21195,7 +21195,7 @@
           <p:cNvPr id="3" name="takeaway">
             <a:extLst xmlns:a="http://schemas.openxmlformats.org/drawingml/2006/main">
               <a:ext uri="{FF2B5EF4-FFF2-40B4-BE49-F238E27FC236}">
-                <a16:creationId xmlns:a16="http://schemas.microsoft.com/office/drawing/2014/main" id="{E10EDB3F-515C-476A-B021-05D1C819856E}"/>
+                <a16:creationId xmlns:a16="http://schemas.microsoft.com/office/drawing/2014/main" id="{8AB076AE-848B-44AA-B5DF-EBD9D00E44AE}"/>
               </a:ext>
             </a:extLst>
           </p:cNvPr>
@@ -21263,7 +21263,7 @@
           <p:cNvPr id="4" name="footer">
             <a:extLst xmlns:a="http://schemas.openxmlformats.org/drawingml/2006/main">
               <a:ext uri="{FF2B5EF4-FFF2-40B4-BE49-F238E27FC236}">
-                <a16:creationId xmlns:a16="http://schemas.microsoft.com/office/drawing/2014/main" id="{A4FBF11F-6A4C-4094-8F8E-6E739FB59E52}"/>
+                <a16:creationId xmlns:a16="http://schemas.microsoft.com/office/drawing/2014/main" id="{B75BC872-CE4B-478A-8300-74E2024916C9}"/>
               </a:ext>
             </a:extLst>
           </p:cNvPr>
@@ -21331,7 +21331,7 @@
           <p:cNvPr id="5" name="slide-number">
             <a:extLst xmlns:a="http://schemas.openxmlformats.org/drawingml/2006/main">
               <a:ext uri="{FF2B5EF4-FFF2-40B4-BE49-F238E27FC236}">
-                <a16:creationId xmlns:a16="http://schemas.microsoft.com/office/drawing/2014/main" id="{1A0FBC39-325B-4F23-AA29-DB6651CD268B}"/>
+                <a16:creationId xmlns:a16="http://schemas.microsoft.com/office/drawing/2014/main" id="{54B2A244-1024-470D-B519-4EF3B0E4F46F}"/>
               </a:ext>
             </a:extLst>
           </p:cNvPr>
@@ -21397,7 +21397,7 @@
     </p:spTree>
     <p:extLst>
       <p:ext uri="{BB962C8B-B14F-4D97-AF65-F5344CB8AC3E}">
-        <p14:creationId xmlns:p14="http://schemas.microsoft.com/office/powerpoint/2010/main" val="424615880"/>
+        <p14:creationId xmlns:p14="http://schemas.microsoft.com/office/powerpoint/2010/main" val="1962525269"/>
       </p:ext>
     </p:extLst>
   </p:cSld>
@@ -21428,7 +21428,7 @@
           <p:cNvPr id="6" name="lesson-title">
             <a:extLst xmlns:a="http://schemas.openxmlformats.org/drawingml/2006/main">
               <a:ext uri="{FF2B5EF4-FFF2-40B4-BE49-F238E27FC236}">
-                <a16:creationId xmlns:a16="http://schemas.microsoft.com/office/drawing/2014/main" id="{57FA9715-8FC2-40AA-BCF4-ED94A08FE8BE}"/>
+                <a16:creationId xmlns:a16="http://schemas.microsoft.com/office/drawing/2014/main" id="{CFD64774-47DB-4E8C-B2A5-DF0ABF0E0D5C}"/>
               </a:ext>
             </a:extLst>
           </p:cNvPr>
@@ -21486,7 +21486,7 @@
                 <a:ea typeface="Bookman Old Style"/>
                 <a:cs typeface="Bookman Old Style"/>
               </a:rPr>
-              <a:t>Checkpoint: open the project folder</a:t>
+              <a:t>Checkpoint 0: run the starter</a:t>
             </a:r>
           </a:p>
         </p:txBody>
@@ -21496,7 +21496,7 @@
           <p:cNvPr id="2" name="code-example">
             <a:extLst xmlns:a="http://schemas.openxmlformats.org/drawingml/2006/main">
               <a:ext uri="{FF2B5EF4-FFF2-40B4-BE49-F238E27FC236}">
-                <a16:creationId xmlns:a16="http://schemas.microsoft.com/office/drawing/2014/main" id="{5A641532-678F-4295-8B55-A9F6333F7DCB}"/>
+                <a16:creationId xmlns:a16="http://schemas.microsoft.com/office/drawing/2014/main" id="{7725BAD3-5858-427E-A500-52794B86F9B3}"/>
               </a:ext>
             </a:extLst>
           </p:cNvPr>
@@ -21615,7 +21615,7 @@
           <p:cNvPr id="3" name="takeaway">
             <a:extLst xmlns:a="http://schemas.openxmlformats.org/drawingml/2006/main">
               <a:ext uri="{FF2B5EF4-FFF2-40B4-BE49-F238E27FC236}">
-                <a16:creationId xmlns:a16="http://schemas.microsoft.com/office/drawing/2014/main" id="{5A69D428-6AC0-44FC-A16F-AF632155FA66}"/>
+                <a16:creationId xmlns:a16="http://schemas.microsoft.com/office/drawing/2014/main" id="{C13C1699-5CD7-4171-B1AA-805C635E3004}"/>
               </a:ext>
             </a:extLst>
           </p:cNvPr>
@@ -21673,7 +21673,7 @@
                 <a:ea typeface="Calibri"/>
                 <a:cs typeface="Calibri"/>
               </a:rPr>
-              <a:t>A working local run lets everyone continue without an API account.</a:t>
+              <a:t>Show 1: ready     2: need help     3: using a saved trace</a:t>
             </a:r>
           </a:p>
         </p:txBody>
@@ -21683,7 +21683,7 @@
           <p:cNvPr id="4" name="footer">
             <a:extLst xmlns:a="http://schemas.openxmlformats.org/drawingml/2006/main">
               <a:ext uri="{FF2B5EF4-FFF2-40B4-BE49-F238E27FC236}">
-                <a16:creationId xmlns:a16="http://schemas.microsoft.com/office/drawing/2014/main" id="{355686C2-C96A-465A-86D9-B97C63D9CAAB}"/>
+                <a16:creationId xmlns:a16="http://schemas.microsoft.com/office/drawing/2014/main" id="{2AE039AA-19C1-4FDA-A3B7-CDF3290C5CAE}"/>
               </a:ext>
             </a:extLst>
           </p:cNvPr>
@@ -21751,7 +21751,7 @@
           <p:cNvPr id="5" name="slide-number">
             <a:extLst xmlns:a="http://schemas.openxmlformats.org/drawingml/2006/main">
               <a:ext uri="{FF2B5EF4-FFF2-40B4-BE49-F238E27FC236}">
-                <a16:creationId xmlns:a16="http://schemas.microsoft.com/office/drawing/2014/main" id="{10CC85B9-259D-4CCA-A45F-7750D2BCF886}"/>
+                <a16:creationId xmlns:a16="http://schemas.microsoft.com/office/drawing/2014/main" id="{871BCACF-60AB-4E61-AAD1-6EE1AC568897}"/>
               </a:ext>
             </a:extLst>
           </p:cNvPr>
@@ -21817,7 +21817,7 @@
     </p:spTree>
     <p:extLst>
       <p:ext uri="{BB962C8B-B14F-4D97-AF65-F5344CB8AC3E}">
-        <p14:creationId xmlns:p14="http://schemas.microsoft.com/office/powerpoint/2010/main" val="1548148167"/>
+        <p14:creationId xmlns:p14="http://schemas.microsoft.com/office/powerpoint/2010/main" val="551032662"/>
       </p:ext>
     </p:extLst>
   </p:cSld>
@@ -21848,7 +21848,7 @@
           <p:cNvPr id="6" name="lesson-title">
             <a:extLst xmlns:a="http://schemas.openxmlformats.org/drawingml/2006/main">
               <a:ext uri="{FF2B5EF4-FFF2-40B4-BE49-F238E27FC236}">
-                <a16:creationId xmlns:a16="http://schemas.microsoft.com/office/drawing/2014/main" id="{F924CCF8-1FA9-44FD-B273-14A76E039256}"/>
+                <a16:creationId xmlns:a16="http://schemas.microsoft.com/office/drawing/2014/main" id="{40D7E7B9-6E09-47CB-80BD-84ABDDA4C0AE}"/>
               </a:ext>
             </a:extLst>
           </p:cNvPr>
@@ -21916,7 +21916,7 @@
           <p:cNvPr id="2" name="code-example">
             <a:extLst xmlns:a="http://schemas.openxmlformats.org/drawingml/2006/main">
               <a:ext uri="{FF2B5EF4-FFF2-40B4-BE49-F238E27FC236}">
-                <a16:creationId xmlns:a16="http://schemas.microsoft.com/office/drawing/2014/main" id="{29A15A2C-18AE-4E30-8C2B-B40472B785D0}"/>
+                <a16:creationId xmlns:a16="http://schemas.microsoft.com/office/drawing/2014/main" id="{5671F340-800E-4F8D-B5F5-33A95A49E244}"/>
               </a:ext>
             </a:extLst>
           </p:cNvPr>
@@ -22099,7 +22099,7 @@
           <p:cNvPr id="3" name="takeaway">
             <a:extLst xmlns:a="http://schemas.openxmlformats.org/drawingml/2006/main">
               <a:ext uri="{FF2B5EF4-FFF2-40B4-BE49-F238E27FC236}">
-                <a16:creationId xmlns:a16="http://schemas.microsoft.com/office/drawing/2014/main" id="{D2386F66-5806-4FDC-B727-DD5B9804C6FA}"/>
+                <a16:creationId xmlns:a16="http://schemas.microsoft.com/office/drawing/2014/main" id="{452A70F1-6306-449B-AA14-6A62B1AD0E11}"/>
               </a:ext>
             </a:extLst>
           </p:cNvPr>
@@ -22167,7 +22167,7 @@
           <p:cNvPr id="4" name="footer">
             <a:extLst xmlns:a="http://schemas.openxmlformats.org/drawingml/2006/main">
               <a:ext uri="{FF2B5EF4-FFF2-40B4-BE49-F238E27FC236}">
-                <a16:creationId xmlns:a16="http://schemas.microsoft.com/office/drawing/2014/main" id="{4D04A759-C0CC-4662-B2A7-FD0AB1A8750E}"/>
+                <a16:creationId xmlns:a16="http://schemas.microsoft.com/office/drawing/2014/main" id="{B939E02F-60CA-4045-BD40-ECC5A9FDBA47}"/>
               </a:ext>
             </a:extLst>
           </p:cNvPr>
@@ -22235,7 +22235,7 @@
           <p:cNvPr id="5" name="slide-number">
             <a:extLst xmlns:a="http://schemas.openxmlformats.org/drawingml/2006/main">
               <a:ext uri="{FF2B5EF4-FFF2-40B4-BE49-F238E27FC236}">
-                <a16:creationId xmlns:a16="http://schemas.microsoft.com/office/drawing/2014/main" id="{E11BF2E7-B20F-4555-9C41-54FAEB301B5C}"/>
+                <a16:creationId xmlns:a16="http://schemas.microsoft.com/office/drawing/2014/main" id="{85DBB1AE-D837-4081-8552-CD13583EDAF3}"/>
               </a:ext>
             </a:extLst>
           </p:cNvPr>
@@ -22301,7 +22301,7 @@
     </p:spTree>
     <p:extLst>
       <p:ext uri="{BB962C8B-B14F-4D97-AF65-F5344CB8AC3E}">
-        <p14:creationId xmlns:p14="http://schemas.microsoft.com/office/powerpoint/2010/main" val="893933536"/>
+        <p14:creationId xmlns:p14="http://schemas.microsoft.com/office/powerpoint/2010/main" val="985530076"/>
       </p:ext>
     </p:extLst>
   </p:cSld>

</xml_diff>